<commit_message>
updated the line tracking ppts
</commit_message>
<xml_diff>
--- a/module-02-line-tracking/slides/08-introduction-to-classes.pptx
+++ b/module-02-line-tracking/slides/08-introduction-to-classes.pptx
@@ -74,13 +74,13 @@
         </a:solidFill>
         <a:effectLst/>
         <a:uFillTx/>
-        <a:latin typeface="+mn-lt"/>
-        <a:ea typeface="+mn-ea"/>
-        <a:cs typeface="+mn-cs"/>
+        <a:latin typeface="+mj-lt"/>
+        <a:ea typeface="+mj-ea"/>
+        <a:cs typeface="+mj-cs"/>
         <a:sym typeface="Calibri"/>
       </a:defRPr>
     </a:lvl1pPr>
-    <a:lvl2pPr marL="0" marR="0" indent="457200" algn="l" defTabSz="457200" rtl="0" fontAlgn="auto" latinLnBrk="0" hangingPunct="0">
+    <a:lvl2pPr marL="0" marR="0" indent="0" algn="l" defTabSz="457200" rtl="0" fontAlgn="auto" latinLnBrk="0" hangingPunct="0">
       <a:lnSpc>
         <a:spcPct val="100000"/>
       </a:lnSpc>
@@ -104,13 +104,13 @@
         </a:solidFill>
         <a:effectLst/>
         <a:uFillTx/>
-        <a:latin typeface="+mn-lt"/>
-        <a:ea typeface="+mn-ea"/>
-        <a:cs typeface="+mn-cs"/>
+        <a:latin typeface="+mj-lt"/>
+        <a:ea typeface="+mj-ea"/>
+        <a:cs typeface="+mj-cs"/>
         <a:sym typeface="Calibri"/>
       </a:defRPr>
     </a:lvl2pPr>
-    <a:lvl3pPr marL="0" marR="0" indent="914400" algn="l" defTabSz="457200" rtl="0" fontAlgn="auto" latinLnBrk="0" hangingPunct="0">
+    <a:lvl3pPr marL="0" marR="0" indent="0" algn="l" defTabSz="457200" rtl="0" fontAlgn="auto" latinLnBrk="0" hangingPunct="0">
       <a:lnSpc>
         <a:spcPct val="100000"/>
       </a:lnSpc>
@@ -134,13 +134,13 @@
         </a:solidFill>
         <a:effectLst/>
         <a:uFillTx/>
-        <a:latin typeface="+mn-lt"/>
-        <a:ea typeface="+mn-ea"/>
-        <a:cs typeface="+mn-cs"/>
+        <a:latin typeface="+mj-lt"/>
+        <a:ea typeface="+mj-ea"/>
+        <a:cs typeface="+mj-cs"/>
         <a:sym typeface="Calibri"/>
       </a:defRPr>
     </a:lvl3pPr>
-    <a:lvl4pPr marL="0" marR="0" indent="1371600" algn="l" defTabSz="457200" rtl="0" fontAlgn="auto" latinLnBrk="0" hangingPunct="0">
+    <a:lvl4pPr marL="0" marR="0" indent="0" algn="l" defTabSz="457200" rtl="0" fontAlgn="auto" latinLnBrk="0" hangingPunct="0">
       <a:lnSpc>
         <a:spcPct val="100000"/>
       </a:lnSpc>
@@ -164,13 +164,13 @@
         </a:solidFill>
         <a:effectLst/>
         <a:uFillTx/>
-        <a:latin typeface="+mn-lt"/>
-        <a:ea typeface="+mn-ea"/>
-        <a:cs typeface="+mn-cs"/>
+        <a:latin typeface="+mj-lt"/>
+        <a:ea typeface="+mj-ea"/>
+        <a:cs typeface="+mj-cs"/>
         <a:sym typeface="Calibri"/>
       </a:defRPr>
     </a:lvl4pPr>
-    <a:lvl5pPr marL="0" marR="0" indent="1828800" algn="l" defTabSz="457200" rtl="0" fontAlgn="auto" latinLnBrk="0" hangingPunct="0">
+    <a:lvl5pPr marL="0" marR="0" indent="0" algn="l" defTabSz="457200" rtl="0" fontAlgn="auto" latinLnBrk="0" hangingPunct="0">
       <a:lnSpc>
         <a:spcPct val="100000"/>
       </a:lnSpc>
@@ -194,13 +194,13 @@
         </a:solidFill>
         <a:effectLst/>
         <a:uFillTx/>
-        <a:latin typeface="+mn-lt"/>
-        <a:ea typeface="+mn-ea"/>
-        <a:cs typeface="+mn-cs"/>
+        <a:latin typeface="+mj-lt"/>
+        <a:ea typeface="+mj-ea"/>
+        <a:cs typeface="+mj-cs"/>
         <a:sym typeface="Calibri"/>
       </a:defRPr>
     </a:lvl5pPr>
-    <a:lvl6pPr marL="0" marR="0" indent="2286000" algn="l" defTabSz="457200" rtl="0" fontAlgn="auto" latinLnBrk="0" hangingPunct="0">
+    <a:lvl6pPr marL="0" marR="0" indent="0" algn="l" defTabSz="457200" rtl="0" fontAlgn="auto" latinLnBrk="0" hangingPunct="0">
       <a:lnSpc>
         <a:spcPct val="100000"/>
       </a:lnSpc>
@@ -224,13 +224,13 @@
         </a:solidFill>
         <a:effectLst/>
         <a:uFillTx/>
-        <a:latin typeface="+mn-lt"/>
-        <a:ea typeface="+mn-ea"/>
-        <a:cs typeface="+mn-cs"/>
+        <a:latin typeface="+mj-lt"/>
+        <a:ea typeface="+mj-ea"/>
+        <a:cs typeface="+mj-cs"/>
         <a:sym typeface="Calibri"/>
       </a:defRPr>
     </a:lvl6pPr>
-    <a:lvl7pPr marL="0" marR="0" indent="2743200" algn="l" defTabSz="457200" rtl="0" fontAlgn="auto" latinLnBrk="0" hangingPunct="0">
+    <a:lvl7pPr marL="0" marR="0" indent="0" algn="l" defTabSz="457200" rtl="0" fontAlgn="auto" latinLnBrk="0" hangingPunct="0">
       <a:lnSpc>
         <a:spcPct val="100000"/>
       </a:lnSpc>
@@ -254,13 +254,13 @@
         </a:solidFill>
         <a:effectLst/>
         <a:uFillTx/>
-        <a:latin typeface="+mn-lt"/>
-        <a:ea typeface="+mn-ea"/>
-        <a:cs typeface="+mn-cs"/>
+        <a:latin typeface="+mj-lt"/>
+        <a:ea typeface="+mj-ea"/>
+        <a:cs typeface="+mj-cs"/>
         <a:sym typeface="Calibri"/>
       </a:defRPr>
     </a:lvl7pPr>
-    <a:lvl8pPr marL="0" marR="0" indent="3200400" algn="l" defTabSz="457200" rtl="0" fontAlgn="auto" latinLnBrk="0" hangingPunct="0">
+    <a:lvl8pPr marL="0" marR="0" indent="0" algn="l" defTabSz="457200" rtl="0" fontAlgn="auto" latinLnBrk="0" hangingPunct="0">
       <a:lnSpc>
         <a:spcPct val="100000"/>
       </a:lnSpc>
@@ -284,13 +284,13 @@
         </a:solidFill>
         <a:effectLst/>
         <a:uFillTx/>
-        <a:latin typeface="+mn-lt"/>
-        <a:ea typeface="+mn-ea"/>
-        <a:cs typeface="+mn-cs"/>
+        <a:latin typeface="+mj-lt"/>
+        <a:ea typeface="+mj-ea"/>
+        <a:cs typeface="+mj-cs"/>
         <a:sym typeface="Calibri"/>
       </a:defRPr>
     </a:lvl8pPr>
-    <a:lvl9pPr marL="0" marR="0" indent="3657600" algn="l" defTabSz="457200" rtl="0" fontAlgn="auto" latinLnBrk="0" hangingPunct="0">
+    <a:lvl9pPr marL="0" marR="0" indent="0" algn="l" defTabSz="457200" rtl="0" fontAlgn="auto" latinLnBrk="0" hangingPunct="0">
       <a:lnSpc>
         <a:spcPct val="100000"/>
       </a:lnSpc>
@@ -314,9 +314,9 @@
         </a:solidFill>
         <a:effectLst/>
         <a:uFillTx/>
-        <a:latin typeface="+mn-lt"/>
-        <a:ea typeface="+mn-ea"/>
-        <a:cs typeface="+mn-cs"/>
+        <a:latin typeface="+mj-lt"/>
+        <a:ea typeface="+mj-ea"/>
+        <a:cs typeface="+mj-cs"/>
         <a:sym typeface="Calibri"/>
       </a:defRPr>
     </a:lvl9pPr>
@@ -401,73 +401,73 @@
   <p:notesStyle>
     <a:lvl1pPr defTabSz="457200" latinLnBrk="0">
       <a:defRPr sz="1200">
-        <a:latin typeface="+mn-lt"/>
-        <a:ea typeface="+mn-ea"/>
-        <a:cs typeface="+mn-cs"/>
+        <a:latin typeface="+mj-lt"/>
+        <a:ea typeface="+mj-ea"/>
+        <a:cs typeface="+mj-cs"/>
         <a:sym typeface="Calibri"/>
       </a:defRPr>
     </a:lvl1pPr>
     <a:lvl2pPr indent="228600" defTabSz="457200" latinLnBrk="0">
       <a:defRPr sz="1200">
-        <a:latin typeface="+mn-lt"/>
-        <a:ea typeface="+mn-ea"/>
-        <a:cs typeface="+mn-cs"/>
+        <a:latin typeface="+mj-lt"/>
+        <a:ea typeface="+mj-ea"/>
+        <a:cs typeface="+mj-cs"/>
         <a:sym typeface="Calibri"/>
       </a:defRPr>
     </a:lvl2pPr>
     <a:lvl3pPr indent="457200" defTabSz="457200" latinLnBrk="0">
       <a:defRPr sz="1200">
-        <a:latin typeface="+mn-lt"/>
-        <a:ea typeface="+mn-ea"/>
-        <a:cs typeface="+mn-cs"/>
+        <a:latin typeface="+mj-lt"/>
+        <a:ea typeface="+mj-ea"/>
+        <a:cs typeface="+mj-cs"/>
         <a:sym typeface="Calibri"/>
       </a:defRPr>
     </a:lvl3pPr>
     <a:lvl4pPr indent="685800" defTabSz="457200" latinLnBrk="0">
       <a:defRPr sz="1200">
-        <a:latin typeface="+mn-lt"/>
-        <a:ea typeface="+mn-ea"/>
-        <a:cs typeface="+mn-cs"/>
+        <a:latin typeface="+mj-lt"/>
+        <a:ea typeface="+mj-ea"/>
+        <a:cs typeface="+mj-cs"/>
         <a:sym typeface="Calibri"/>
       </a:defRPr>
     </a:lvl4pPr>
     <a:lvl5pPr indent="914400" defTabSz="457200" latinLnBrk="0">
       <a:defRPr sz="1200">
-        <a:latin typeface="+mn-lt"/>
-        <a:ea typeface="+mn-ea"/>
-        <a:cs typeface="+mn-cs"/>
+        <a:latin typeface="+mj-lt"/>
+        <a:ea typeface="+mj-ea"/>
+        <a:cs typeface="+mj-cs"/>
         <a:sym typeface="Calibri"/>
       </a:defRPr>
     </a:lvl5pPr>
     <a:lvl6pPr indent="1143000" defTabSz="457200" latinLnBrk="0">
       <a:defRPr sz="1200">
-        <a:latin typeface="+mn-lt"/>
-        <a:ea typeface="+mn-ea"/>
-        <a:cs typeface="+mn-cs"/>
+        <a:latin typeface="+mj-lt"/>
+        <a:ea typeface="+mj-ea"/>
+        <a:cs typeface="+mj-cs"/>
         <a:sym typeface="Calibri"/>
       </a:defRPr>
     </a:lvl6pPr>
     <a:lvl7pPr indent="1371600" defTabSz="457200" latinLnBrk="0">
       <a:defRPr sz="1200">
-        <a:latin typeface="+mn-lt"/>
-        <a:ea typeface="+mn-ea"/>
-        <a:cs typeface="+mn-cs"/>
+        <a:latin typeface="+mj-lt"/>
+        <a:ea typeface="+mj-ea"/>
+        <a:cs typeface="+mj-cs"/>
         <a:sym typeface="Calibri"/>
       </a:defRPr>
     </a:lvl7pPr>
     <a:lvl8pPr indent="1600200" defTabSz="457200" latinLnBrk="0">
       <a:defRPr sz="1200">
-        <a:latin typeface="+mn-lt"/>
-        <a:ea typeface="+mn-ea"/>
-        <a:cs typeface="+mn-cs"/>
+        <a:latin typeface="+mj-lt"/>
+        <a:ea typeface="+mj-ea"/>
+        <a:cs typeface="+mj-cs"/>
         <a:sym typeface="Calibri"/>
       </a:defRPr>
     </a:lvl8pPr>
     <a:lvl9pPr indent="1828800" defTabSz="457200" latinLnBrk="0">
       <a:defRPr sz="1200">
-        <a:latin typeface="+mn-lt"/>
-        <a:ea typeface="+mn-ea"/>
-        <a:cs typeface="+mn-cs"/>
+        <a:latin typeface="+mj-lt"/>
+        <a:ea typeface="+mj-ea"/>
+        <a:cs typeface="+mj-cs"/>
         <a:sym typeface="Calibri"/>
       </a:defRPr>
     </a:lvl9pPr>
@@ -550,7 +550,7 @@
                 </a:solidFill>
               </a:defRPr>
             </a:lvl1pPr>
-            <a:lvl2pPr marL="0" indent="457200" algn="ctr">
+            <a:lvl2pPr marL="0" indent="0" algn="ctr">
               <a:buSzTx/>
               <a:buFontTx/>
               <a:buNone/>
@@ -560,7 +560,7 @@
                 </a:solidFill>
               </a:defRPr>
             </a:lvl2pPr>
-            <a:lvl3pPr marL="0" indent="914400" algn="ctr">
+            <a:lvl3pPr marL="0" indent="0" algn="ctr">
               <a:buSzTx/>
               <a:buFontTx/>
               <a:buNone/>
@@ -570,7 +570,7 @@
                 </a:solidFill>
               </a:defRPr>
             </a:lvl3pPr>
-            <a:lvl4pPr marL="0" indent="1371600" algn="ctr">
+            <a:lvl4pPr marL="0" indent="0" algn="ctr">
               <a:buSzTx/>
               <a:buFontTx/>
               <a:buNone/>
@@ -580,7 +580,7 @@
                 </a:solidFill>
               </a:defRPr>
             </a:lvl4pPr>
-            <a:lvl5pPr marL="0" indent="1828800" algn="ctr">
+            <a:lvl5pPr marL="0" indent="0" algn="ctr">
               <a:buSzTx/>
               <a:buFontTx/>
               <a:buNone/>
@@ -680,10 +680,6 @@
           </p:nvPr>
         </p:nvSpPr>
         <p:spPr>
-          <a:xfrm>
-            <a:off x="457200" y="274638"/>
-            <a:ext cx="8229600" cy="1143001"/>
-          </a:xfrm>
           <a:prstGeom prst="rect">
             <a:avLst/>
           </a:prstGeom>
@@ -708,10 +704,6 @@
           </p:nvPr>
         </p:nvSpPr>
         <p:spPr>
-          <a:xfrm>
-            <a:off x="457200" y="1600200"/>
-            <a:ext cx="8229600" cy="4525963"/>
-          </a:xfrm>
           <a:prstGeom prst="rect">
             <a:avLst/>
           </a:prstGeom>
@@ -842,7 +834,7 @@
         <p:spPr>
           <a:xfrm>
             <a:off x="722312" y="2906713"/>
-            <a:ext cx="7772401" cy="1500188"/>
+            <a:ext cx="7772401" cy="1500189"/>
           </a:xfrm>
           <a:prstGeom prst="rect">
             <a:avLst/>
@@ -864,7 +856,7 @@
                 </a:solidFill>
               </a:defRPr>
             </a:lvl1pPr>
-            <a:lvl2pPr marL="0" indent="457200">
+            <a:lvl2pPr marL="0" indent="0">
               <a:spcBef>
                 <a:spcPts val="400"/>
               </a:spcBef>
@@ -877,7 +869,7 @@
                 </a:solidFill>
               </a:defRPr>
             </a:lvl2pPr>
-            <a:lvl3pPr marL="0" indent="914400">
+            <a:lvl3pPr marL="0" indent="0">
               <a:spcBef>
                 <a:spcPts val="400"/>
               </a:spcBef>
@@ -890,7 +882,7 @@
                 </a:solidFill>
               </a:defRPr>
             </a:lvl3pPr>
-            <a:lvl4pPr marL="0" indent="1371600">
+            <a:lvl4pPr marL="0" indent="0">
               <a:spcBef>
                 <a:spcPts val="400"/>
               </a:spcBef>
@@ -903,7 +895,7 @@
                 </a:solidFill>
               </a:defRPr>
             </a:lvl4pPr>
-            <a:lvl5pPr marL="0" indent="1828800">
+            <a:lvl5pPr marL="0" indent="0">
               <a:spcBef>
                 <a:spcPts val="400"/>
               </a:spcBef>
@@ -1006,10 +998,6 @@
           </p:nvPr>
         </p:nvSpPr>
         <p:spPr>
-          <a:xfrm>
-            <a:off x="457200" y="274638"/>
-            <a:ext cx="8229600" cy="1143001"/>
-          </a:xfrm>
           <a:prstGeom prst="rect">
             <a:avLst/>
           </a:prstGeom>
@@ -1057,7 +1045,7 @@
               </a:spcBef>
               <a:defRPr sz="2800"/>
             </a:lvl2pPr>
-            <a:lvl3pPr marL="1234439" indent="-320039">
+            <a:lvl3pPr marL="1234438" indent="-320038">
               <a:spcBef>
                 <a:spcPts val="600"/>
               </a:spcBef>
@@ -1165,10 +1153,6 @@
           </p:nvPr>
         </p:nvSpPr>
         <p:spPr>
-          <a:xfrm>
-            <a:off x="457200" y="274638"/>
-            <a:ext cx="8229600" cy="1143001"/>
-          </a:xfrm>
           <a:prstGeom prst="rect">
             <a:avLst/>
           </a:prstGeom>
@@ -1213,7 +1197,7 @@
               <a:buNone/>
               <a:defRPr b="1" sz="2400"/>
             </a:lvl1pPr>
-            <a:lvl2pPr marL="0" indent="457200">
+            <a:lvl2pPr marL="0" indent="0">
               <a:spcBef>
                 <a:spcPts val="500"/>
               </a:spcBef>
@@ -1222,7 +1206,7 @@
               <a:buNone/>
               <a:defRPr b="1" sz="2400"/>
             </a:lvl2pPr>
-            <a:lvl3pPr marL="0" indent="914400">
+            <a:lvl3pPr marL="0" indent="0">
               <a:spcBef>
                 <a:spcPts val="500"/>
               </a:spcBef>
@@ -1231,7 +1215,7 @@
               <a:buNone/>
               <a:defRPr b="1" sz="2400"/>
             </a:lvl3pPr>
-            <a:lvl4pPr marL="0" indent="1371600">
+            <a:lvl4pPr marL="0" indent="0">
               <a:spcBef>
                 <a:spcPts val="500"/>
               </a:spcBef>
@@ -1240,7 +1224,7 @@
               <a:buNone/>
               <a:defRPr b="1" sz="2400"/>
             </a:lvl4pPr>
-            <a:lvl5pPr marL="0" indent="1828800">
+            <a:lvl5pPr marL="0" indent="0">
               <a:spcBef>
                 <a:spcPts val="500"/>
               </a:spcBef>
@@ -1292,8 +1276,8 @@
         </p:nvSpPr>
         <p:spPr>
           <a:xfrm>
-            <a:off x="4645025" y="1535112"/>
-            <a:ext cx="4041775" cy="639763"/>
+            <a:off x="4645025" y="1535111"/>
+            <a:ext cx="4041775" cy="639765"/>
           </a:xfrm>
           <a:prstGeom prst="rect">
             <a:avLst/>
@@ -1303,15 +1287,7 @@
           <a:bodyPr anchor="b"/>
           <a:lstStyle/>
           <a:p>
-            <a:pPr marL="0" indent="0">
-              <a:spcBef>
-                <a:spcPts val="500"/>
-              </a:spcBef>
-              <a:buSzTx/>
-              <a:buFontTx/>
-              <a:buNone/>
-              <a:defRPr b="1" sz="2400"/>
-            </a:pPr>
+            <a:pPr/>
           </a:p>
         </p:txBody>
       </p:sp>
@@ -1372,10 +1348,6 @@
           </p:nvPr>
         </p:nvSpPr>
         <p:spPr>
-          <a:xfrm>
-            <a:off x="457200" y="274638"/>
-            <a:ext cx="8229600" cy="1143001"/>
-          </a:xfrm>
           <a:prstGeom prst="rect">
             <a:avLst/>
           </a:prstGeom>
@@ -1498,7 +1470,7 @@
         <p:spPr>
           <a:xfrm>
             <a:off x="457200" y="273050"/>
-            <a:ext cx="3008314" cy="1162050"/>
+            <a:ext cx="3008315" cy="1162050"/>
           </a:xfrm>
           <a:prstGeom prst="rect">
             <a:avLst/>
@@ -1581,8 +1553,8 @@
         </p:nvSpPr>
         <p:spPr>
           <a:xfrm>
-            <a:off x="457199" y="1435100"/>
-            <a:ext cx="3008315" cy="4691063"/>
+            <a:off x="457198" y="1435100"/>
+            <a:ext cx="3008316" cy="4691063"/>
           </a:xfrm>
           <a:prstGeom prst="rect">
             <a:avLst/>
@@ -1592,15 +1564,7 @@
           <a:bodyPr/>
           <a:lstStyle/>
           <a:p>
-            <a:pPr marL="0" indent="0">
-              <a:spcBef>
-                <a:spcPts val="300"/>
-              </a:spcBef>
-              <a:buSzTx/>
-              <a:buFontTx/>
-              <a:buNone/>
-              <a:defRPr sz="1400"/>
-            </a:pPr>
+            <a:pPr/>
           </a:p>
         </p:txBody>
       </p:sp>
@@ -1663,7 +1627,7 @@
         <p:spPr>
           <a:xfrm>
             <a:off x="1792288" y="4800600"/>
-            <a:ext cx="5486401" cy="566738"/>
+            <a:ext cx="5486402" cy="566738"/>
           </a:xfrm>
           <a:prstGeom prst="rect">
             <a:avLst/>
@@ -1695,14 +1659,14 @@
         <p:spPr>
           <a:xfrm>
             <a:off x="1792288" y="612775"/>
-            <a:ext cx="5486401" cy="4114800"/>
+            <a:ext cx="5486402" cy="4114800"/>
           </a:xfrm>
           <a:prstGeom prst="rect">
             <a:avLst/>
           </a:prstGeom>
         </p:spPr>
         <p:txBody>
-          <a:bodyPr lIns="91439" rIns="91439">
+          <a:bodyPr lIns="91439" tIns="45719" rIns="91439" bIns="45719">
             <a:noAutofit/>
           </a:bodyPr>
           <a:lstStyle/>
@@ -1722,7 +1686,7 @@
         <p:spPr>
           <a:xfrm>
             <a:off x="1792288" y="5367337"/>
-            <a:ext cx="5486401" cy="804863"/>
+            <a:ext cx="5486402" cy="804864"/>
           </a:xfrm>
           <a:prstGeom prst="rect">
             <a:avLst/>
@@ -1740,7 +1704,7 @@
               <a:buNone/>
               <a:defRPr sz="1400"/>
             </a:lvl1pPr>
-            <a:lvl2pPr marL="0" indent="457200">
+            <a:lvl2pPr marL="0" indent="0">
               <a:spcBef>
                 <a:spcPts val="300"/>
               </a:spcBef>
@@ -1749,7 +1713,7 @@
               <a:buNone/>
               <a:defRPr sz="1400"/>
             </a:lvl2pPr>
-            <a:lvl3pPr marL="0" indent="914400">
+            <a:lvl3pPr marL="0" indent="0">
               <a:spcBef>
                 <a:spcPts val="300"/>
               </a:spcBef>
@@ -1758,7 +1722,7 @@
               <a:buNone/>
               <a:defRPr sz="1400"/>
             </a:lvl3pPr>
-            <a:lvl4pPr marL="0" indent="1371600">
+            <a:lvl4pPr marL="0" indent="0">
               <a:spcBef>
                 <a:spcPts val="300"/>
               </a:spcBef>
@@ -1767,7 +1731,7 @@
               <a:buNone/>
               <a:defRPr sz="1400"/>
             </a:lvl4pPr>
-            <a:lvl5pPr marL="0" indent="1828800">
+            <a:lvl5pPr marL="0" indent="0">
               <a:spcBef>
                 <a:spcPts val="300"/>
               </a:spcBef>
@@ -1874,8 +1838,8 @@
         </p:nvSpPr>
         <p:spPr>
           <a:xfrm>
-            <a:off x="608965" y="92074"/>
-            <a:ext cx="10961370" cy="1508127"/>
+            <a:off x="457200" y="274638"/>
+            <a:ext cx="8229600" cy="1143001"/>
           </a:xfrm>
           <a:prstGeom prst="rect">
             <a:avLst/>
@@ -1890,7 +1854,7 @@
           </a:extLst>
         </p:spPr>
         <p:txBody>
-          <a:bodyPr lIns="45719" rIns="45719" anchor="ctr">
+          <a:bodyPr lIns="45718" tIns="45718" rIns="45718" bIns="45718" anchor="ctr">
             <a:normAutofit fontScale="100000" lnSpcReduction="0"/>
           </a:bodyPr>
           <a:lstStyle/>
@@ -1912,8 +1876,8 @@
         </p:nvSpPr>
         <p:spPr>
           <a:xfrm>
-            <a:off x="608965" y="1600200"/>
-            <a:ext cx="10961370" cy="5257800"/>
+            <a:off x="457200" y="1600200"/>
+            <a:ext cx="8229600" cy="4525963"/>
           </a:xfrm>
           <a:prstGeom prst="rect">
             <a:avLst/>
@@ -1928,7 +1892,7 @@
           </a:extLst>
         </p:spPr>
         <p:txBody>
-          <a:bodyPr lIns="45719" rIns="45719">
+          <a:bodyPr lIns="45718" tIns="45718" rIns="45718" bIns="45718">
             <a:normAutofit fontScale="100000" lnSpcReduction="0"/>
           </a:bodyPr>
           <a:lstStyle/>
@@ -1974,8 +1938,8 @@
         </p:nvSpPr>
         <p:spPr>
           <a:xfrm>
-            <a:off x="8428176" y="6414760"/>
-            <a:ext cx="258624" cy="248305"/>
+            <a:off x="8428178" y="6414761"/>
+            <a:ext cx="258623" cy="248303"/>
           </a:xfrm>
           <a:prstGeom prst="rect">
             <a:avLst/>
@@ -1985,7 +1949,7 @@
           </a:ln>
         </p:spPr>
         <p:txBody>
-          <a:bodyPr wrap="none" lIns="45719" rIns="45719" anchor="ctr">
+          <a:bodyPr wrap="none" lIns="45718" tIns="45718" rIns="45718" bIns="45718" anchor="ctr">
             <a:spAutoFit/>
           </a:bodyPr>
           <a:lstStyle>
@@ -2040,9 +2004,9 @@
             <a:srgbClr val="000000"/>
           </a:solidFill>
           <a:uFillTx/>
-          <a:latin typeface="+mn-lt"/>
-          <a:ea typeface="+mn-ea"/>
-          <a:cs typeface="+mn-cs"/>
+          <a:latin typeface="+mj-lt"/>
+          <a:ea typeface="+mj-ea"/>
+          <a:cs typeface="+mj-cs"/>
           <a:sym typeface="Calibri"/>
         </a:defRPr>
       </a:lvl1pPr>
@@ -2066,9 +2030,9 @@
             <a:srgbClr val="000000"/>
           </a:solidFill>
           <a:uFillTx/>
-          <a:latin typeface="+mn-lt"/>
-          <a:ea typeface="+mn-ea"/>
-          <a:cs typeface="+mn-cs"/>
+          <a:latin typeface="+mj-lt"/>
+          <a:ea typeface="+mj-ea"/>
+          <a:cs typeface="+mj-cs"/>
           <a:sym typeface="Calibri"/>
         </a:defRPr>
       </a:lvl2pPr>
@@ -2092,9 +2056,9 @@
             <a:srgbClr val="000000"/>
           </a:solidFill>
           <a:uFillTx/>
-          <a:latin typeface="+mn-lt"/>
-          <a:ea typeface="+mn-ea"/>
-          <a:cs typeface="+mn-cs"/>
+          <a:latin typeface="+mj-lt"/>
+          <a:ea typeface="+mj-ea"/>
+          <a:cs typeface="+mj-cs"/>
           <a:sym typeface="Calibri"/>
         </a:defRPr>
       </a:lvl3pPr>
@@ -2118,9 +2082,9 @@
             <a:srgbClr val="000000"/>
           </a:solidFill>
           <a:uFillTx/>
-          <a:latin typeface="+mn-lt"/>
-          <a:ea typeface="+mn-ea"/>
-          <a:cs typeface="+mn-cs"/>
+          <a:latin typeface="+mj-lt"/>
+          <a:ea typeface="+mj-ea"/>
+          <a:cs typeface="+mj-cs"/>
           <a:sym typeface="Calibri"/>
         </a:defRPr>
       </a:lvl4pPr>
@@ -2144,9 +2108,9 @@
             <a:srgbClr val="000000"/>
           </a:solidFill>
           <a:uFillTx/>
-          <a:latin typeface="+mn-lt"/>
-          <a:ea typeface="+mn-ea"/>
-          <a:cs typeface="+mn-cs"/>
+          <a:latin typeface="+mj-lt"/>
+          <a:ea typeface="+mj-ea"/>
+          <a:cs typeface="+mj-cs"/>
           <a:sym typeface="Calibri"/>
         </a:defRPr>
       </a:lvl5pPr>
@@ -2170,9 +2134,9 @@
             <a:srgbClr val="000000"/>
           </a:solidFill>
           <a:uFillTx/>
-          <a:latin typeface="+mn-lt"/>
-          <a:ea typeface="+mn-ea"/>
-          <a:cs typeface="+mn-cs"/>
+          <a:latin typeface="+mj-lt"/>
+          <a:ea typeface="+mj-ea"/>
+          <a:cs typeface="+mj-cs"/>
           <a:sym typeface="Calibri"/>
         </a:defRPr>
       </a:lvl6pPr>
@@ -2196,9 +2160,9 @@
             <a:srgbClr val="000000"/>
           </a:solidFill>
           <a:uFillTx/>
-          <a:latin typeface="+mn-lt"/>
-          <a:ea typeface="+mn-ea"/>
-          <a:cs typeface="+mn-cs"/>
+          <a:latin typeface="+mj-lt"/>
+          <a:ea typeface="+mj-ea"/>
+          <a:cs typeface="+mj-cs"/>
           <a:sym typeface="Calibri"/>
         </a:defRPr>
       </a:lvl7pPr>
@@ -2222,9 +2186,9 @@
             <a:srgbClr val="000000"/>
           </a:solidFill>
           <a:uFillTx/>
-          <a:latin typeface="+mn-lt"/>
-          <a:ea typeface="+mn-ea"/>
-          <a:cs typeface="+mn-cs"/>
+          <a:latin typeface="+mj-lt"/>
+          <a:ea typeface="+mj-ea"/>
+          <a:cs typeface="+mj-cs"/>
           <a:sym typeface="Calibri"/>
         </a:defRPr>
       </a:lvl8pPr>
@@ -2248,9 +2212,9 @@
             <a:srgbClr val="000000"/>
           </a:solidFill>
           <a:uFillTx/>
-          <a:latin typeface="+mn-lt"/>
-          <a:ea typeface="+mn-ea"/>
-          <a:cs typeface="+mn-cs"/>
+          <a:latin typeface="+mj-lt"/>
+          <a:ea typeface="+mj-ea"/>
+          <a:cs typeface="+mj-cs"/>
           <a:sym typeface="Calibri"/>
         </a:defRPr>
       </a:lvl9pPr>
@@ -2276,9 +2240,9 @@
             <a:srgbClr val="000000"/>
           </a:solidFill>
           <a:uFillTx/>
-          <a:latin typeface="+mn-lt"/>
-          <a:ea typeface="+mn-ea"/>
-          <a:cs typeface="+mn-cs"/>
+          <a:latin typeface="+mj-lt"/>
+          <a:ea typeface="+mj-ea"/>
+          <a:cs typeface="+mj-cs"/>
           <a:sym typeface="Calibri"/>
         </a:defRPr>
       </a:lvl1pPr>
@@ -2302,9 +2266,9 @@
             <a:srgbClr val="000000"/>
           </a:solidFill>
           <a:uFillTx/>
-          <a:latin typeface="+mn-lt"/>
-          <a:ea typeface="+mn-ea"/>
-          <a:cs typeface="+mn-cs"/>
+          <a:latin typeface="+mj-lt"/>
+          <a:ea typeface="+mj-ea"/>
+          <a:cs typeface="+mj-cs"/>
           <a:sym typeface="Calibri"/>
         </a:defRPr>
       </a:lvl2pPr>
@@ -2328,9 +2292,9 @@
             <a:srgbClr val="000000"/>
           </a:solidFill>
           <a:uFillTx/>
-          <a:latin typeface="+mn-lt"/>
-          <a:ea typeface="+mn-ea"/>
-          <a:cs typeface="+mn-cs"/>
+          <a:latin typeface="+mj-lt"/>
+          <a:ea typeface="+mj-ea"/>
+          <a:cs typeface="+mj-cs"/>
           <a:sym typeface="Calibri"/>
         </a:defRPr>
       </a:lvl3pPr>
@@ -2354,9 +2318,9 @@
             <a:srgbClr val="000000"/>
           </a:solidFill>
           <a:uFillTx/>
-          <a:latin typeface="+mn-lt"/>
-          <a:ea typeface="+mn-ea"/>
-          <a:cs typeface="+mn-cs"/>
+          <a:latin typeface="+mj-lt"/>
+          <a:ea typeface="+mj-ea"/>
+          <a:cs typeface="+mj-cs"/>
           <a:sym typeface="Calibri"/>
         </a:defRPr>
       </a:lvl4pPr>
@@ -2380,9 +2344,9 @@
             <a:srgbClr val="000000"/>
           </a:solidFill>
           <a:uFillTx/>
-          <a:latin typeface="+mn-lt"/>
-          <a:ea typeface="+mn-ea"/>
-          <a:cs typeface="+mn-cs"/>
+          <a:latin typeface="+mj-lt"/>
+          <a:ea typeface="+mj-ea"/>
+          <a:cs typeface="+mj-cs"/>
           <a:sym typeface="Calibri"/>
         </a:defRPr>
       </a:lvl5pPr>
@@ -2406,9 +2370,9 @@
             <a:srgbClr val="000000"/>
           </a:solidFill>
           <a:uFillTx/>
-          <a:latin typeface="+mn-lt"/>
-          <a:ea typeface="+mn-ea"/>
-          <a:cs typeface="+mn-cs"/>
+          <a:latin typeface="+mj-lt"/>
+          <a:ea typeface="+mj-ea"/>
+          <a:cs typeface="+mj-cs"/>
           <a:sym typeface="Calibri"/>
         </a:defRPr>
       </a:lvl6pPr>
@@ -2432,9 +2396,9 @@
             <a:srgbClr val="000000"/>
           </a:solidFill>
           <a:uFillTx/>
-          <a:latin typeface="+mn-lt"/>
-          <a:ea typeface="+mn-ea"/>
-          <a:cs typeface="+mn-cs"/>
+          <a:latin typeface="+mj-lt"/>
+          <a:ea typeface="+mj-ea"/>
+          <a:cs typeface="+mj-cs"/>
           <a:sym typeface="Calibri"/>
         </a:defRPr>
       </a:lvl7pPr>
@@ -2458,9 +2422,9 @@
             <a:srgbClr val="000000"/>
           </a:solidFill>
           <a:uFillTx/>
-          <a:latin typeface="+mn-lt"/>
-          <a:ea typeface="+mn-ea"/>
-          <a:cs typeface="+mn-cs"/>
+          <a:latin typeface="+mj-lt"/>
+          <a:ea typeface="+mj-ea"/>
+          <a:cs typeface="+mj-cs"/>
           <a:sym typeface="Calibri"/>
         </a:defRPr>
       </a:lvl8pPr>
@@ -2484,9 +2448,9 @@
             <a:srgbClr val="000000"/>
           </a:solidFill>
           <a:uFillTx/>
-          <a:latin typeface="+mn-lt"/>
-          <a:ea typeface="+mn-ea"/>
-          <a:cs typeface="+mn-cs"/>
+          <a:latin typeface="+mj-lt"/>
+          <a:ea typeface="+mj-ea"/>
+          <a:cs typeface="+mj-cs"/>
           <a:sym typeface="Calibri"/>
         </a:defRPr>
       </a:lvl9pPr>
@@ -2518,7 +2482,7 @@
           <a:sym typeface="Calibri"/>
         </a:defRPr>
       </a:lvl1pPr>
-      <a:lvl2pPr marL="0" marR="0" indent="457200" algn="r" defTabSz="457200" rtl="0" latinLnBrk="0">
+      <a:lvl2pPr marL="0" marR="0" indent="0" algn="r" defTabSz="457200" rtl="0" latinLnBrk="0">
         <a:lnSpc>
           <a:spcPct val="100000"/>
         </a:lnSpc>
@@ -2544,7 +2508,7 @@
           <a:sym typeface="Calibri"/>
         </a:defRPr>
       </a:lvl2pPr>
-      <a:lvl3pPr marL="0" marR="0" indent="914400" algn="r" defTabSz="457200" rtl="0" latinLnBrk="0">
+      <a:lvl3pPr marL="0" marR="0" indent="0" algn="r" defTabSz="457200" rtl="0" latinLnBrk="0">
         <a:lnSpc>
           <a:spcPct val="100000"/>
         </a:lnSpc>
@@ -2570,7 +2534,7 @@
           <a:sym typeface="Calibri"/>
         </a:defRPr>
       </a:lvl3pPr>
-      <a:lvl4pPr marL="0" marR="0" indent="1371600" algn="r" defTabSz="457200" rtl="0" latinLnBrk="0">
+      <a:lvl4pPr marL="0" marR="0" indent="0" algn="r" defTabSz="457200" rtl="0" latinLnBrk="0">
         <a:lnSpc>
           <a:spcPct val="100000"/>
         </a:lnSpc>
@@ -2596,7 +2560,7 @@
           <a:sym typeface="Calibri"/>
         </a:defRPr>
       </a:lvl4pPr>
-      <a:lvl5pPr marL="0" marR="0" indent="1828800" algn="r" defTabSz="457200" rtl="0" latinLnBrk="0">
+      <a:lvl5pPr marL="0" marR="0" indent="0" algn="r" defTabSz="457200" rtl="0" latinLnBrk="0">
         <a:lnSpc>
           <a:spcPct val="100000"/>
         </a:lnSpc>
@@ -2622,7 +2586,7 @@
           <a:sym typeface="Calibri"/>
         </a:defRPr>
       </a:lvl5pPr>
-      <a:lvl6pPr marL="0" marR="0" indent="2286000" algn="r" defTabSz="457200" rtl="0" latinLnBrk="0">
+      <a:lvl6pPr marL="0" marR="0" indent="0" algn="r" defTabSz="457200" rtl="0" latinLnBrk="0">
         <a:lnSpc>
           <a:spcPct val="100000"/>
         </a:lnSpc>
@@ -2648,7 +2612,7 @@
           <a:sym typeface="Calibri"/>
         </a:defRPr>
       </a:lvl6pPr>
-      <a:lvl7pPr marL="0" marR="0" indent="2743200" algn="r" defTabSz="457200" rtl="0" latinLnBrk="0">
+      <a:lvl7pPr marL="0" marR="0" indent="0" algn="r" defTabSz="457200" rtl="0" latinLnBrk="0">
         <a:lnSpc>
           <a:spcPct val="100000"/>
         </a:lnSpc>
@@ -2674,7 +2638,7 @@
           <a:sym typeface="Calibri"/>
         </a:defRPr>
       </a:lvl7pPr>
-      <a:lvl8pPr marL="0" marR="0" indent="3200400" algn="r" defTabSz="457200" rtl="0" latinLnBrk="0">
+      <a:lvl8pPr marL="0" marR="0" indent="0" algn="r" defTabSz="457200" rtl="0" latinLnBrk="0">
         <a:lnSpc>
           <a:spcPct val="100000"/>
         </a:lnSpc>
@@ -2700,7 +2664,7 @@
           <a:sym typeface="Calibri"/>
         </a:defRPr>
       </a:lvl8pPr>
-      <a:lvl9pPr marL="0" marR="0" indent="3657600" algn="r" defTabSz="457200" rtl="0" latinLnBrk="0">
+      <a:lvl9pPr marL="0" marR="0" indent="0" algn="r" defTabSz="457200" rtl="0" latinLnBrk="0">
         <a:lnSpc>
           <a:spcPct val="100000"/>
         </a:lnSpc>
@@ -2777,7 +2741,7 @@
           </a:effectLst>
         </p:spPr>
         <p:txBody>
-          <a:bodyPr lIns="45719" rIns="45719" anchor="ctr"/>
+          <a:bodyPr lIns="45718" tIns="45718" rIns="45718" bIns="45718" anchor="ctr"/>
           <a:lstStyle/>
           <a:p>
             <a:pPr algn="ctr">
@@ -2798,8 +2762,8 @@
         </p:nvSpPr>
         <p:spPr>
           <a:xfrm>
-            <a:off x="777239" y="457199"/>
-            <a:ext cx="2547899" cy="340183"/>
+            <a:off x="777238" y="457199"/>
+            <a:ext cx="2547897" cy="340181"/>
           </a:xfrm>
           <a:prstGeom prst="rect">
             <a:avLst/>
@@ -2814,7 +2778,7 @@
           </a:extLst>
         </p:spPr>
         <p:txBody>
-          <a:bodyPr wrap="none" lIns="45719" rIns="45719">
+          <a:bodyPr wrap="none" lIns="45718" tIns="45718" rIns="45718" bIns="45718">
             <a:spAutoFit/>
           </a:bodyPr>
           <a:lstStyle>
@@ -2842,8 +2806,8 @@
         </p:nvSpPr>
         <p:spPr>
           <a:xfrm>
-            <a:off x="777239" y="914400"/>
-            <a:ext cx="8471953" cy="542241"/>
+            <a:off x="777239" y="914401"/>
+            <a:ext cx="8471950" cy="542239"/>
           </a:xfrm>
           <a:prstGeom prst="rect">
             <a:avLst/>
@@ -2858,7 +2822,7 @@
           </a:extLst>
         </p:spPr>
         <p:txBody>
-          <a:bodyPr wrap="none" lIns="45719" rIns="45719">
+          <a:bodyPr wrap="none" lIns="45718" tIns="45718" rIns="45718" bIns="45718">
             <a:spAutoFit/>
           </a:bodyPr>
           <a:lstStyle>
@@ -2886,8 +2850,8 @@
         </p:nvSpPr>
         <p:spPr>
           <a:xfrm>
-            <a:off x="777239" y="3108960"/>
-            <a:ext cx="4828957" cy="1656691"/>
+            <a:off x="777238" y="3108961"/>
+            <a:ext cx="4828955" cy="1720189"/>
           </a:xfrm>
           <a:prstGeom prst="rect">
             <a:avLst/>
@@ -2902,7 +2866,7 @@
           </a:extLst>
         </p:spPr>
         <p:txBody>
-          <a:bodyPr wrap="none" lIns="45719" rIns="45719">
+          <a:bodyPr wrap="none" lIns="45718" tIns="45718" rIns="45718" bIns="45718">
             <a:spAutoFit/>
           </a:bodyPr>
           <a:lstStyle/>
@@ -2988,8 +2952,8 @@
         </p:nvSpPr>
         <p:spPr>
           <a:xfrm>
-            <a:off x="6903719" y="3108960"/>
-            <a:ext cx="4153358" cy="1608694"/>
+            <a:off x="6903718" y="3108961"/>
+            <a:ext cx="4153356" cy="1672192"/>
           </a:xfrm>
           <a:prstGeom prst="rect">
             <a:avLst/>
@@ -3004,7 +2968,7 @@
           </a:extLst>
         </p:spPr>
         <p:txBody>
-          <a:bodyPr wrap="none" lIns="45719" rIns="45719">
+          <a:bodyPr wrap="none" lIns="45718" tIns="45718" rIns="45718" bIns="45718">
             <a:spAutoFit/>
           </a:bodyPr>
           <a:lstStyle/>
@@ -3137,7 +3101,7 @@
           </a:effectLst>
         </p:spPr>
         <p:txBody>
-          <a:bodyPr lIns="45719" rIns="45719" anchor="ctr"/>
+          <a:bodyPr lIns="45718" tIns="45718" rIns="45718" bIns="45718" anchor="ctr"/>
           <a:lstStyle/>
           <a:p>
             <a:pPr algn="ctr">
@@ -3159,7 +3123,7 @@
         <p:spPr>
           <a:xfrm>
             <a:off x="594360" y="137159"/>
-            <a:ext cx="10881361" cy="489954"/>
+            <a:ext cx="10881361" cy="489952"/>
           </a:xfrm>
           <a:prstGeom prst="rect">
             <a:avLst/>
@@ -3174,7 +3138,7 @@
           </a:extLst>
         </p:spPr>
         <p:txBody>
-          <a:bodyPr lIns="45719" rIns="45719">
+          <a:bodyPr lIns="45718" tIns="45718" rIns="45718" bIns="45718">
             <a:spAutoFit/>
           </a:bodyPr>
           <a:lstStyle>
@@ -3227,7 +3191,7 @@
           </a:effectLst>
         </p:spPr>
         <p:txBody>
-          <a:bodyPr lIns="45719" rIns="45719" anchor="ctr"/>
+          <a:bodyPr lIns="45718" tIns="45718" rIns="45718" bIns="45718" anchor="ctr"/>
           <a:lstStyle/>
           <a:p>
             <a:pPr algn="ctr">
@@ -3248,8 +3212,8 @@
         </p:nvSpPr>
         <p:spPr>
           <a:xfrm>
-            <a:off x="777239" y="1371599"/>
-            <a:ext cx="6445013" cy="4752341"/>
+            <a:off x="777238" y="1371600"/>
+            <a:ext cx="6445011" cy="3533139"/>
           </a:xfrm>
           <a:prstGeom prst="rect">
             <a:avLst/>
@@ -3264,7 +3228,7 @@
           </a:extLst>
         </p:spPr>
         <p:txBody>
-          <a:bodyPr wrap="none" lIns="45719" rIns="45719">
+          <a:bodyPr wrap="none" lIns="45718" tIns="45718" rIns="45718" bIns="45718">
             <a:spAutoFit/>
           </a:bodyPr>
           <a:lstStyle/>
@@ -3411,115 +3375,7 @@
               </a:defRPr>
             </a:pPr>
             <a:r>
-              <a:t>    def get_left(self):</a:t>
-            </a:r>
-          </a:p>
-          <a:p>
-            <a:pPr>
-              <a:spcBef>
-                <a:spcPts val="100"/>
-              </a:spcBef>
-              <a:defRPr sz="1300">
-                <a:solidFill>
-                  <a:srgbClr val="333333"/>
-                </a:solidFill>
-                <a:latin typeface="Courier New"/>
-                <a:ea typeface="Courier New"/>
-                <a:cs typeface="Courier New"/>
-                <a:sym typeface="Courier New"/>
-              </a:defRPr>
-            </a:pPr>
-            <a:r>
-              <a:t>        return self.reflectance.get_left()</a:t>
-            </a:r>
-          </a:p>
-          <a:p>
-            <a:pPr>
-              <a:spcBef>
-                <a:spcPts val="100"/>
-              </a:spcBef>
-              <a:defRPr sz="1300">
-                <a:solidFill>
-                  <a:srgbClr val="333333"/>
-                </a:solidFill>
-                <a:latin typeface="Courier New"/>
-                <a:ea typeface="Courier New"/>
-                <a:cs typeface="Courier New"/>
-                <a:sym typeface="Courier New"/>
-              </a:defRPr>
-            </a:pPr>
-          </a:p>
-          <a:p>
-            <a:pPr>
-              <a:spcBef>
-                <a:spcPts val="100"/>
-              </a:spcBef>
-              <a:defRPr sz="1300">
-                <a:solidFill>
-                  <a:srgbClr val="333333"/>
-                </a:solidFill>
-                <a:latin typeface="Courier New"/>
-                <a:ea typeface="Courier New"/>
-                <a:cs typeface="Courier New"/>
-                <a:sym typeface="Courier New"/>
-              </a:defRPr>
-            </a:pPr>
-            <a:r>
-              <a:t>    def get_right(self):</a:t>
-            </a:r>
-          </a:p>
-          <a:p>
-            <a:pPr>
-              <a:spcBef>
-                <a:spcPts val="100"/>
-              </a:spcBef>
-              <a:defRPr sz="1300">
-                <a:solidFill>
-                  <a:srgbClr val="333333"/>
-                </a:solidFill>
-                <a:latin typeface="Courier New"/>
-                <a:ea typeface="Courier New"/>
-                <a:cs typeface="Courier New"/>
-                <a:sym typeface="Courier New"/>
-              </a:defRPr>
-            </a:pPr>
-            <a:r>
-              <a:t>        return self.reflectance.get_right()</a:t>
-            </a:r>
-          </a:p>
-          <a:p>
-            <a:pPr>
-              <a:spcBef>
-                <a:spcPts val="100"/>
-              </a:spcBef>
-              <a:defRPr sz="1300">
-                <a:solidFill>
-                  <a:srgbClr val="333333"/>
-                </a:solidFill>
-                <a:latin typeface="Courier New"/>
-                <a:ea typeface="Courier New"/>
-                <a:cs typeface="Courier New"/>
-                <a:sym typeface="Courier New"/>
-              </a:defRPr>
-            </a:pPr>
-          </a:p>
-          <a:p>
-            <a:pPr>
-              <a:spcBef>
-                <a:spcPts val="100"/>
-              </a:spcBef>
-              <a:defRPr sz="1300">
-                <a:solidFill>
-                  <a:srgbClr val="333333"/>
-                </a:solidFill>
-                <a:latin typeface="Courier New"/>
-                <a:ea typeface="Courier New"/>
-                <a:cs typeface="Courier New"/>
-                <a:sym typeface="Courier New"/>
-              </a:defRPr>
-            </a:pPr>
-            <a:r>
-              <a:t>    def get_error(self):</a:t>
+              <a:t>   def get_error(self):</a:t>
             </a:r>
           </a:p>
           <a:p>
@@ -3698,7 +3554,7 @@
         <p:spPr>
           <a:xfrm>
             <a:off x="8549639" y="1280159"/>
-            <a:ext cx="3383281" cy="3948298"/>
+            <a:ext cx="3383282" cy="3427595"/>
           </a:xfrm>
           <a:prstGeom prst="rect">
             <a:avLst/>
@@ -3713,7 +3569,7 @@
           </a:extLst>
         </p:spPr>
         <p:txBody>
-          <a:bodyPr lIns="45719" rIns="45719">
+          <a:bodyPr lIns="45718" tIns="45718" rIns="45718" bIns="45718">
             <a:spAutoFit/>
           </a:bodyPr>
           <a:lstStyle/>
@@ -3781,7 +3637,7 @@
             </a:r>
           </a:p>
           <a:p>
-            <a:pPr lvl="1">
+            <a:pPr lvl="1" indent="457200">
               <a:spcBef>
                 <a:spcPts val="500"/>
               </a:spcBef>
@@ -3796,7 +3652,7 @@
             </a:r>
           </a:p>
           <a:p>
-            <a:pPr lvl="1">
+            <a:pPr lvl="1" indent="457200">
               <a:spcBef>
                 <a:spcPts val="500"/>
               </a:spcBef>
@@ -3822,11 +3678,11 @@
               </a:defRPr>
             </a:pPr>
             <a:r>
-              <a:t>5 methods:</a:t>
-            </a:r>
-          </a:p>
-          <a:p>
-            <a:pPr lvl="1">
+              <a:t>3 methods:</a:t>
+            </a:r>
+          </a:p>
+          <a:p>
+            <a:pPr lvl="1" indent="457200">
               <a:spcBef>
                 <a:spcPts val="500"/>
               </a:spcBef>
@@ -3837,11 +3693,11 @@
               </a:defRPr>
             </a:pPr>
             <a:r>
-              <a:t>get_left</a:t>
-            </a:r>
-          </a:p>
-          <a:p>
-            <a:pPr lvl="1">
+              <a:t>get_error</a:t>
+            </a:r>
+          </a:p>
+          <a:p>
+            <a:pPr lvl="1" indent="457200">
               <a:spcBef>
                 <a:spcPts val="500"/>
               </a:spcBef>
@@ -3852,41 +3708,11 @@
               </a:defRPr>
             </a:pPr>
             <a:r>
-              <a:t>get_right</a:t>
-            </a:r>
-          </a:p>
-          <a:p>
-            <a:pPr lvl="1">
-              <a:spcBef>
-                <a:spcPts val="500"/>
-              </a:spcBef>
-              <a:defRPr sz="1500">
-                <a:solidFill>
-                  <a:srgbClr val="333333"/>
-                </a:solidFill>
-              </a:defRPr>
-            </a:pPr>
-            <a:r>
-              <a:t>get_error</a:t>
-            </a:r>
-          </a:p>
-          <a:p>
-            <a:pPr lvl="1">
-              <a:spcBef>
-                <a:spcPts val="500"/>
-              </a:spcBef>
-              <a:defRPr sz="1500">
-                <a:solidFill>
-                  <a:srgbClr val="333333"/>
-                </a:solidFill>
-              </a:defRPr>
-            </a:pPr>
-            <a:r>
               <a:t>is_at_cross</a:t>
             </a:r>
           </a:p>
           <a:p>
-            <a:pPr lvl="1">
+            <a:pPr lvl="1" indent="457200">
               <a:spcBef>
                 <a:spcPts val="500"/>
               </a:spcBef>
@@ -3957,7 +3783,7 @@
           </a:effectLst>
         </p:spPr>
         <p:txBody>
-          <a:bodyPr lIns="45719" rIns="45719" anchor="ctr"/>
+          <a:bodyPr lIns="45718" tIns="45718" rIns="45718" bIns="45718" anchor="ctr"/>
           <a:lstStyle/>
           <a:p>
             <a:pPr algn="ctr">
@@ -3979,7 +3805,7 @@
         <p:spPr>
           <a:xfrm>
             <a:off x="594360" y="137159"/>
-            <a:ext cx="10881361" cy="489954"/>
+            <a:ext cx="10881361" cy="489952"/>
           </a:xfrm>
           <a:prstGeom prst="rect">
             <a:avLst/>
@@ -3994,7 +3820,7 @@
           </a:extLst>
         </p:spPr>
         <p:txBody>
-          <a:bodyPr lIns="45719" rIns="45719">
+          <a:bodyPr lIns="45718" tIns="45718" rIns="45718" bIns="45718">
             <a:spAutoFit/>
           </a:bodyPr>
           <a:lstStyle>
@@ -4022,8 +3848,8 @@
         </p:nvSpPr>
         <p:spPr>
           <a:xfrm>
-            <a:off x="594360" y="1188719"/>
-            <a:ext cx="5394961" cy="333089"/>
+            <a:off x="594359" y="1188720"/>
+            <a:ext cx="5394962" cy="333086"/>
           </a:xfrm>
           <a:prstGeom prst="rect">
             <a:avLst/>
@@ -4038,7 +3864,7 @@
           </a:extLst>
         </p:spPr>
         <p:txBody>
-          <a:bodyPr lIns="45719" rIns="45719">
+          <a:bodyPr lIns="45718" tIns="45718" rIns="45718" bIns="45718">
             <a:spAutoFit/>
           </a:bodyPr>
           <a:lstStyle>
@@ -4067,7 +3893,7 @@
         <p:spPr>
           <a:xfrm>
             <a:off x="548640" y="1737360"/>
-            <a:ext cx="5486401" cy="2926080"/>
+            <a:ext cx="5486402" cy="2926080"/>
           </a:xfrm>
           <a:prstGeom prst="roundRect">
             <a:avLst>
@@ -4091,7 +3917,7 @@
           </a:effectLst>
         </p:spPr>
         <p:txBody>
-          <a:bodyPr lIns="45719" rIns="45719" anchor="ctr"/>
+          <a:bodyPr lIns="45718" tIns="45718" rIns="45718" bIns="45718" anchor="ctr"/>
           <a:lstStyle/>
           <a:p>
             <a:pPr algn="ctr">
@@ -4112,8 +3938,8 @@
         </p:nvSpPr>
         <p:spPr>
           <a:xfrm>
-            <a:off x="777239" y="1828800"/>
-            <a:ext cx="5157024" cy="1704340"/>
+            <a:off x="777239" y="1828801"/>
+            <a:ext cx="5157021" cy="1704339"/>
           </a:xfrm>
           <a:prstGeom prst="rect">
             <a:avLst/>
@@ -4128,7 +3954,7 @@
           </a:extLst>
         </p:spPr>
         <p:txBody>
-          <a:bodyPr wrap="none" lIns="45719" rIns="45719">
+          <a:bodyPr wrap="none" lIns="45718" tIns="45718" rIns="45718" bIns="45718">
             <a:spAutoFit/>
           </a:bodyPr>
           <a:lstStyle/>
@@ -4291,8 +4117,8 @@
         </p:nvSpPr>
         <p:spPr>
           <a:xfrm>
-            <a:off x="6446519" y="1188719"/>
-            <a:ext cx="5394962" cy="333089"/>
+            <a:off x="6446518" y="1188720"/>
+            <a:ext cx="5394963" cy="333086"/>
           </a:xfrm>
           <a:prstGeom prst="rect">
             <a:avLst/>
@@ -4307,7 +4133,7 @@
           </a:extLst>
         </p:spPr>
         <p:txBody>
-          <a:bodyPr lIns="45719" rIns="45719">
+          <a:bodyPr lIns="45718" tIns="45718" rIns="45718" bIns="45718">
             <a:spAutoFit/>
           </a:bodyPr>
           <a:lstStyle>
@@ -4360,7 +4186,7 @@
           </a:effectLst>
         </p:spPr>
         <p:txBody>
-          <a:bodyPr lIns="45719" rIns="45719" anchor="ctr"/>
+          <a:bodyPr lIns="45718" tIns="45718" rIns="45718" bIns="45718" anchor="ctr"/>
           <a:lstStyle/>
           <a:p>
             <a:pPr algn="ctr">
@@ -4381,8 +4207,8 @@
         </p:nvSpPr>
         <p:spPr>
           <a:xfrm>
-            <a:off x="6629400" y="1828800"/>
-            <a:ext cx="3175501" cy="1094740"/>
+            <a:off x="6629399" y="1828801"/>
+            <a:ext cx="3175499" cy="1094739"/>
           </a:xfrm>
           <a:prstGeom prst="rect">
             <a:avLst/>
@@ -4397,7 +4223,7 @@
           </a:extLst>
         </p:spPr>
         <p:txBody>
-          <a:bodyPr wrap="none" lIns="45719" rIns="45719">
+          <a:bodyPr wrap="none" lIns="45718" tIns="45718" rIns="45718" bIns="45718">
             <a:spAutoFit/>
           </a:bodyPr>
           <a:lstStyle/>
@@ -4503,8 +4329,8 @@
         </p:nvSpPr>
         <p:spPr>
           <a:xfrm>
-            <a:off x="594360" y="4937759"/>
-            <a:ext cx="10881361" cy="1265794"/>
+            <a:off x="594360" y="4937760"/>
+            <a:ext cx="10881361" cy="1329292"/>
           </a:xfrm>
           <a:prstGeom prst="rect">
             <a:avLst/>
@@ -4519,7 +4345,7 @@
           </a:extLst>
         </p:spPr>
         <p:txBody>
-          <a:bodyPr lIns="45719" rIns="45719">
+          <a:bodyPr lIns="45718" tIns="45718" rIns="45718" bIns="45718">
             <a:spAutoFit/>
           </a:bodyPr>
           <a:lstStyle/>
@@ -4628,7 +4454,7 @@
           </a:effectLst>
         </p:spPr>
         <p:txBody>
-          <a:bodyPr lIns="45719" rIns="45719" anchor="ctr"/>
+          <a:bodyPr lIns="45718" tIns="45718" rIns="45718" bIns="45718" anchor="ctr"/>
           <a:lstStyle/>
           <a:p>
             <a:pPr algn="ctr">
@@ -4650,7 +4476,7 @@
         <p:spPr>
           <a:xfrm>
             <a:off x="594360" y="137159"/>
-            <a:ext cx="10881361" cy="489954"/>
+            <a:ext cx="10881361" cy="489952"/>
           </a:xfrm>
           <a:prstGeom prst="rect">
             <a:avLst/>
@@ -4665,7 +4491,7 @@
           </a:extLst>
         </p:spPr>
         <p:txBody>
-          <a:bodyPr lIns="45719" rIns="45719">
+          <a:bodyPr lIns="45718" tIns="45718" rIns="45718" bIns="45718">
             <a:spAutoFit/>
           </a:bodyPr>
           <a:lstStyle>
@@ -4693,8 +4519,8 @@
         </p:nvSpPr>
         <p:spPr>
           <a:xfrm>
-            <a:off x="594360" y="1188719"/>
-            <a:ext cx="10881361" cy="333089"/>
+            <a:off x="594360" y="1188720"/>
+            <a:ext cx="10881361" cy="333086"/>
           </a:xfrm>
           <a:prstGeom prst="rect">
             <a:avLst/>
@@ -4709,7 +4535,7 @@
           </a:extLst>
         </p:spPr>
         <p:txBody>
-          <a:bodyPr lIns="45719" rIns="45719">
+          <a:bodyPr lIns="45718" tIns="45718" rIns="45718" bIns="45718">
             <a:spAutoFit/>
           </a:bodyPr>
           <a:lstStyle>
@@ -4738,7 +4564,7 @@
         <p:spPr>
           <a:xfrm>
             <a:off x="548640" y="1737360"/>
-            <a:ext cx="10972801" cy="2638793"/>
+            <a:ext cx="10972801" cy="2638794"/>
           </a:xfrm>
           <a:prstGeom prst="roundRect">
             <a:avLst>
@@ -4762,7 +4588,7 @@
           </a:effectLst>
         </p:spPr>
         <p:txBody>
-          <a:bodyPr lIns="45719" rIns="45719" anchor="ctr"/>
+          <a:bodyPr lIns="45718" tIns="45718" rIns="45718" bIns="45718" anchor="ctr"/>
           <a:lstStyle/>
           <a:p>
             <a:pPr algn="ctr">
@@ -4783,8 +4609,8 @@
         </p:nvSpPr>
         <p:spPr>
           <a:xfrm>
-            <a:off x="777239" y="1828799"/>
-            <a:ext cx="6841318" cy="2313941"/>
+            <a:off x="777238" y="1828799"/>
+            <a:ext cx="6841316" cy="2313939"/>
           </a:xfrm>
           <a:prstGeom prst="rect">
             <a:avLst/>
@@ -4799,7 +4625,7 @@
           </a:extLst>
         </p:spPr>
         <p:txBody>
-          <a:bodyPr wrap="none" lIns="45719" rIns="45719">
+          <a:bodyPr wrap="none" lIns="45718" tIns="45718" rIns="45718" bIns="45718">
             <a:spAutoFit/>
           </a:bodyPr>
           <a:lstStyle/>
@@ -5017,7 +4843,7 @@
         <p:spPr>
           <a:xfrm>
             <a:off x="466902" y="4591704"/>
-            <a:ext cx="10881361" cy="958192"/>
+            <a:ext cx="10881361" cy="1021690"/>
           </a:xfrm>
           <a:prstGeom prst="rect">
             <a:avLst/>
@@ -5032,7 +4858,7 @@
           </a:extLst>
         </p:spPr>
         <p:txBody>
-          <a:bodyPr lIns="45719" rIns="45719">
+          <a:bodyPr lIns="45718" tIns="45718" rIns="45718" bIns="45718">
             <a:spAutoFit/>
           </a:bodyPr>
           <a:lstStyle/>
@@ -5079,8 +4905,8 @@
         </p:nvSpPr>
         <p:spPr>
           <a:xfrm>
-            <a:off x="421182" y="5323224"/>
-            <a:ext cx="9144001" cy="1371601"/>
+            <a:off x="421181" y="5323223"/>
+            <a:ext cx="9144002" cy="1371602"/>
           </a:xfrm>
           <a:prstGeom prst="roundRect">
             <a:avLst>
@@ -5104,7 +4930,7 @@
           </a:effectLst>
         </p:spPr>
         <p:txBody>
-          <a:bodyPr lIns="45719" rIns="45719" anchor="ctr"/>
+          <a:bodyPr lIns="45718" tIns="45718" rIns="45718" bIns="45718" anchor="ctr"/>
           <a:lstStyle/>
           <a:p>
             <a:pPr algn="ctr">
@@ -5125,8 +4951,8 @@
         </p:nvSpPr>
         <p:spPr>
           <a:xfrm>
-            <a:off x="649782" y="5414664"/>
-            <a:ext cx="7633926" cy="891541"/>
+            <a:off x="649781" y="5414665"/>
+            <a:ext cx="7633925" cy="891539"/>
           </a:xfrm>
           <a:prstGeom prst="rect">
             <a:avLst/>
@@ -5141,7 +4967,7 @@
           </a:extLst>
         </p:spPr>
         <p:txBody>
-          <a:bodyPr wrap="none" lIns="45719" rIns="45719">
+          <a:bodyPr wrap="none" lIns="45718" tIns="45718" rIns="45718" bIns="45718">
             <a:spAutoFit/>
           </a:bodyPr>
           <a:lstStyle/>
@@ -5278,7 +5104,7 @@
           </a:effectLst>
         </p:spPr>
         <p:txBody>
-          <a:bodyPr lIns="45719" rIns="45719" anchor="ctr"/>
+          <a:bodyPr lIns="45718" tIns="45718" rIns="45718" bIns="45718" anchor="ctr"/>
           <a:lstStyle/>
           <a:p>
             <a:pPr algn="ctr">
@@ -5300,7 +5126,7 @@
         <p:spPr>
           <a:xfrm>
             <a:off x="594360" y="137159"/>
-            <a:ext cx="10881361" cy="489954"/>
+            <a:ext cx="10881361" cy="489952"/>
           </a:xfrm>
           <a:prstGeom prst="rect">
             <a:avLst/>
@@ -5315,7 +5141,7 @@
           </a:extLst>
         </p:spPr>
         <p:txBody>
-          <a:bodyPr lIns="45719" rIns="45719">
+          <a:bodyPr lIns="45718" tIns="45718" rIns="45718" bIns="45718">
             <a:spAutoFit/>
           </a:bodyPr>
           <a:lstStyle>
@@ -5343,8 +5169,8 @@
         </p:nvSpPr>
         <p:spPr>
           <a:xfrm>
-            <a:off x="594360" y="1188719"/>
-            <a:ext cx="10881361" cy="333089"/>
+            <a:off x="594360" y="1188720"/>
+            <a:ext cx="10881361" cy="333086"/>
           </a:xfrm>
           <a:prstGeom prst="rect">
             <a:avLst/>
@@ -5359,7 +5185,7 @@
           </a:extLst>
         </p:spPr>
         <p:txBody>
-          <a:bodyPr lIns="45719" rIns="45719">
+          <a:bodyPr lIns="45718" tIns="45718" rIns="45718" bIns="45718">
             <a:spAutoFit/>
           </a:bodyPr>
           <a:lstStyle>
@@ -5412,7 +5238,7 @@
           </a:effectLst>
         </p:spPr>
         <p:txBody>
-          <a:bodyPr lIns="45719" rIns="45719" anchor="ctr"/>
+          <a:bodyPr lIns="45718" tIns="45718" rIns="45718" bIns="45718" anchor="ctr"/>
           <a:lstStyle/>
           <a:p>
             <a:pPr algn="ctr">
@@ -5433,8 +5259,8 @@
         </p:nvSpPr>
         <p:spPr>
           <a:xfrm>
-            <a:off x="777239" y="1828799"/>
-            <a:ext cx="6445013" cy="3126741"/>
+            <a:off x="777238" y="1828799"/>
+            <a:ext cx="6445011" cy="3126739"/>
           </a:xfrm>
           <a:prstGeom prst="rect">
             <a:avLst/>
@@ -5449,7 +5275,7 @@
           </a:extLst>
         </p:spPr>
         <p:txBody>
-          <a:bodyPr wrap="none" lIns="45719" rIns="45719">
+          <a:bodyPr wrap="none" lIns="45718" tIns="45718" rIns="45718" bIns="45718">
             <a:spAutoFit/>
           </a:bodyPr>
           <a:lstStyle/>
@@ -5745,8 +5571,8 @@
         </p:nvSpPr>
         <p:spPr>
           <a:xfrm>
-            <a:off x="8458200" y="1737360"/>
-            <a:ext cx="3474720" cy="2980294"/>
+            <a:off x="8458199" y="1737361"/>
+            <a:ext cx="3474722" cy="3043792"/>
           </a:xfrm>
           <a:prstGeom prst="rect">
             <a:avLst/>
@@ -5761,7 +5587,7 @@
           </a:extLst>
         </p:spPr>
         <p:txBody>
-          <a:bodyPr lIns="45719" rIns="45719">
+          <a:bodyPr lIns="45718" tIns="45718" rIns="45718" bIns="45718">
             <a:spAutoFit/>
           </a:bodyPr>
           <a:lstStyle/>
@@ -5833,12 +5659,12 @@
               <a:spcBef>
                 <a:spcPts val="500"/>
               </a:spcBef>
-            </a:pPr>
-            <a:endParaRPr sz="1600">
-              <a:solidFill>
-                <a:srgbClr val="333333"/>
-              </a:solidFill>
-            </a:endParaRPr>
+              <a:defRPr sz="1600">
+                <a:solidFill>
+                  <a:srgbClr val="333333"/>
+                </a:solidFill>
+              </a:defRPr>
+            </a:pPr>
           </a:p>
           <a:p>
             <a:pPr>
@@ -5912,7 +5738,7 @@
           </a:effectLst>
         </p:spPr>
         <p:txBody>
-          <a:bodyPr lIns="45719" rIns="45719" anchor="ctr"/>
+          <a:bodyPr lIns="45718" tIns="45718" rIns="45718" bIns="45718" anchor="ctr"/>
           <a:lstStyle/>
           <a:p>
             <a:pPr algn="ctr">
@@ -5934,7 +5760,7 @@
         <p:spPr>
           <a:xfrm>
             <a:off x="594360" y="137159"/>
-            <a:ext cx="10881361" cy="489954"/>
+            <a:ext cx="10881361" cy="489952"/>
           </a:xfrm>
           <a:prstGeom prst="rect">
             <a:avLst/>
@@ -5949,7 +5775,7 @@
           </a:extLst>
         </p:spPr>
         <p:txBody>
-          <a:bodyPr lIns="45719" rIns="45719">
+          <a:bodyPr lIns="45718" tIns="45718" rIns="45718" bIns="45718">
             <a:spAutoFit/>
           </a:bodyPr>
           <a:lstStyle>
@@ -5977,8 +5803,8 @@
         </p:nvSpPr>
         <p:spPr>
           <a:xfrm>
-            <a:off x="594360" y="1280160"/>
-            <a:ext cx="7357651" cy="340182"/>
+            <a:off x="594360" y="1280161"/>
+            <a:ext cx="7357649" cy="340180"/>
           </a:xfrm>
           <a:prstGeom prst="rect">
             <a:avLst/>
@@ -5993,7 +5819,7 @@
           </a:extLst>
         </p:spPr>
         <p:txBody>
-          <a:bodyPr wrap="none" lIns="45719" rIns="45719">
+          <a:bodyPr wrap="none" lIns="45718" tIns="45718" rIns="45718" bIns="45718">
             <a:spAutoFit/>
           </a:bodyPr>
           <a:lstStyle>
@@ -6021,8 +5847,8 @@
         </p:nvSpPr>
         <p:spPr>
           <a:xfrm>
-            <a:off x="594360" y="2011679"/>
-            <a:ext cx="4937761" cy="3335895"/>
+            <a:off x="594359" y="2011679"/>
+            <a:ext cx="4937762" cy="3399393"/>
           </a:xfrm>
           <a:prstGeom prst="rect">
             <a:avLst/>
@@ -6037,7 +5863,7 @@
           </a:extLst>
         </p:spPr>
         <p:txBody>
-          <a:bodyPr lIns="45719" rIns="45719">
+          <a:bodyPr lIns="45718" tIns="45718" rIns="45718" bIns="45718">
             <a:spAutoFit/>
           </a:bodyPr>
           <a:lstStyle/>
@@ -6060,7 +5886,7 @@
             </a:r>
           </a:p>
           <a:p>
-            <a:pPr lvl="1">
+            <a:pPr lvl="1" indent="457200">
               <a:spcBef>
                 <a:spcPts val="500"/>
               </a:spcBef>
@@ -6075,7 +5901,7 @@
             </a:r>
           </a:p>
           <a:p>
-            <a:pPr lvl="1">
+            <a:pPr lvl="1" indent="457200">
               <a:spcBef>
                 <a:spcPts val="500"/>
               </a:spcBef>
@@ -6094,12 +5920,12 @@
               <a:spcBef>
                 <a:spcPts val="500"/>
               </a:spcBef>
-            </a:pPr>
-            <a:endParaRPr sz="1600">
-              <a:solidFill>
-                <a:srgbClr val="333333"/>
-              </a:solidFill>
-            </a:endParaRPr>
+              <a:defRPr sz="1600">
+                <a:solidFill>
+                  <a:srgbClr val="333333"/>
+                </a:solidFill>
+              </a:defRPr>
+            </a:pPr>
           </a:p>
           <a:p>
             <a:pPr>
@@ -6117,7 +5943,7 @@
             </a:r>
           </a:p>
           <a:p>
-            <a:pPr lvl="1">
+            <a:pPr lvl="1" indent="457200">
               <a:spcBef>
                 <a:spcPts val="500"/>
               </a:spcBef>
@@ -6132,7 +5958,7 @@
             </a:r>
           </a:p>
           <a:p>
-            <a:pPr lvl="1">
+            <a:pPr lvl="1" indent="457200">
               <a:spcBef>
                 <a:spcPts val="500"/>
               </a:spcBef>
@@ -6155,8 +5981,8 @@
           <p:nvPr/>
         </p:nvGraphicFramePr>
         <p:xfrm>
-          <a:off x="6160046" y="2490906"/>
-          <a:ext cx="5813894" cy="2390141"/>
+          <a:off x="6160046" y="2490905"/>
+          <a:ext cx="5801193" cy="2377437"/>
         </p:xfrm>
         <a:graphic xmlns:a="http://schemas.openxmlformats.org/drawingml/2006/main">
           <a:graphicData uri="http://schemas.openxmlformats.org/drawingml/2006/table">
@@ -6437,7 +6263,7 @@
           </a:effectLst>
         </p:spPr>
         <p:txBody>
-          <a:bodyPr lIns="45719" rIns="45719" anchor="ctr"/>
+          <a:bodyPr lIns="45718" tIns="45718" rIns="45718" bIns="45718" anchor="ctr"/>
           <a:lstStyle/>
           <a:p>
             <a:pPr algn="ctr">
@@ -6459,7 +6285,7 @@
         <p:spPr>
           <a:xfrm>
             <a:off x="594360" y="137159"/>
-            <a:ext cx="10881361" cy="489954"/>
+            <a:ext cx="10881361" cy="489952"/>
           </a:xfrm>
           <a:prstGeom prst="rect">
             <a:avLst/>
@@ -6474,7 +6300,7 @@
           </a:extLst>
         </p:spPr>
         <p:txBody>
-          <a:bodyPr lIns="45719" rIns="45719">
+          <a:bodyPr lIns="45718" tIns="45718" rIns="45718" bIns="45718">
             <a:spAutoFit/>
           </a:bodyPr>
           <a:lstStyle>
@@ -6502,8 +6328,8 @@
         </p:nvSpPr>
         <p:spPr>
           <a:xfrm>
-            <a:off x="594360" y="1280160"/>
-            <a:ext cx="10881361" cy="333088"/>
+            <a:off x="594360" y="1280161"/>
+            <a:ext cx="10881361" cy="333086"/>
           </a:xfrm>
           <a:prstGeom prst="rect">
             <a:avLst/>
@@ -6518,7 +6344,7 @@
           </a:extLst>
         </p:spPr>
         <p:txBody>
-          <a:bodyPr lIns="45719" rIns="45719">
+          <a:bodyPr lIns="45718" tIns="45718" rIns="45718" bIns="45718">
             <a:spAutoFit/>
           </a:bodyPr>
           <a:lstStyle>
@@ -6571,7 +6397,7 @@
           </a:effectLst>
         </p:spPr>
         <p:txBody>
-          <a:bodyPr lIns="45719" rIns="45719" anchor="ctr"/>
+          <a:bodyPr lIns="45718" tIns="45718" rIns="45718" bIns="45718" anchor="ctr"/>
           <a:lstStyle/>
           <a:p>
             <a:pPr algn="ctr">
@@ -6592,8 +6418,8 @@
         </p:nvSpPr>
         <p:spPr>
           <a:xfrm>
-            <a:off x="777239" y="1920239"/>
-            <a:ext cx="6345937" cy="891541"/>
+            <a:off x="777238" y="1920239"/>
+            <a:ext cx="8502746" cy="1247139"/>
           </a:xfrm>
           <a:prstGeom prst="rect">
             <a:avLst/>
@@ -6608,7 +6434,7 @@
           </a:extLst>
         </p:spPr>
         <p:txBody>
-          <a:bodyPr wrap="none" lIns="45719" rIns="45719">
+          <a:bodyPr wrap="none" lIns="45718" tIns="45718" rIns="45718" bIns="45718">
             <a:spAutoFit/>
           </a:bodyPr>
           <a:lstStyle/>
@@ -6617,7 +6443,7 @@
               <a:spcBef>
                 <a:spcPts val="100"/>
               </a:spcBef>
-              <a:defRPr sz="1300">
+              <a:defRPr sz="1900">
                 <a:solidFill>
                   <a:srgbClr val="333333"/>
                 </a:solidFill>
@@ -6628,7 +6454,7 @@
               </a:defRPr>
             </a:pPr>
             <a:r>
-              <a:t>drivetrain = DifferentialDrive.get_default_differential_drive()</a:t>
+              <a:t>Drive = DifferentialDrive.get_default_differential_drive()</a:t>
             </a:r>
           </a:p>
           <a:p>
@@ -6636,7 +6462,7 @@
               <a:spcBef>
                 <a:spcPts val="100"/>
               </a:spcBef>
-              <a:defRPr sz="1300">
+              <a:defRPr sz="1900">
                 <a:solidFill>
                   <a:srgbClr val="333333"/>
                 </a:solidFill>
@@ -6647,7 +6473,7 @@
               </a:defRPr>
             </a:pPr>
             <a:r>
-              <a:t>drivetrain.straight(30)</a:t>
+              <a:t>drive.straight(30)</a:t>
             </a:r>
           </a:p>
           <a:p>
@@ -6655,7 +6481,7 @@
               <a:spcBef>
                 <a:spcPts val="100"/>
               </a:spcBef>
-              <a:defRPr sz="1300">
+              <a:defRPr sz="1900">
                 <a:solidFill>
                   <a:srgbClr val="333333"/>
                 </a:solidFill>
@@ -6666,7 +6492,7 @@
               </a:defRPr>
             </a:pPr>
             <a:r>
-              <a:t>drivetrain.turn(90)</a:t>
+              <a:t>drive.turn(90)</a:t>
             </a:r>
           </a:p>
           <a:p>
@@ -6674,7 +6500,7 @@
               <a:spcBef>
                 <a:spcPts val="100"/>
               </a:spcBef>
-              <a:defRPr sz="1300">
+              <a:defRPr sz="1900">
                 <a:solidFill>
                   <a:srgbClr val="333333"/>
                 </a:solidFill>
@@ -6685,7 +6511,7 @@
               </a:defRPr>
             </a:pPr>
             <a:r>
-              <a:t>drivetrain.stop()</a:t>
+              <a:t>drive.stop()</a:t>
             </a:r>
           </a:p>
         </p:txBody>
@@ -6698,8 +6524,8 @@
         </p:nvSpPr>
         <p:spPr>
           <a:xfrm>
-            <a:off x="594360" y="4023359"/>
-            <a:ext cx="10881361" cy="2054683"/>
+            <a:off x="594360" y="4023360"/>
+            <a:ext cx="10881361" cy="2118180"/>
           </a:xfrm>
           <a:prstGeom prst="rect">
             <a:avLst/>
@@ -6714,7 +6540,7 @@
           </a:extLst>
         </p:spPr>
         <p:txBody>
-          <a:bodyPr lIns="45719" rIns="45719">
+          <a:bodyPr lIns="45718" tIns="45718" rIns="45718" bIns="45718">
             <a:spAutoFit/>
           </a:bodyPr>
           <a:lstStyle/>
@@ -6748,7 +6574,7 @@
               </a:defRPr>
             </a:pPr>
             <a:r>
-              <a:t>drivetrain is an object (a specific instance)</a:t>
+              <a:t>drive is an object (a specific instance)</a:t>
             </a:r>
           </a:p>
           <a:p>
@@ -6771,12 +6597,12 @@
               <a:spcBef>
                 <a:spcPts val="500"/>
               </a:spcBef>
-            </a:pPr>
-            <a:endParaRPr sz="1900">
-              <a:solidFill>
-                <a:srgbClr val="333333"/>
-              </a:solidFill>
-            </a:endParaRPr>
+              <a:defRPr sz="1900">
+                <a:solidFill>
+                  <a:srgbClr val="333333"/>
+                </a:solidFill>
+              </a:defRPr>
+            </a:pPr>
           </a:p>
           <a:p>
             <a:pPr>
@@ -6850,7 +6676,7 @@
           </a:effectLst>
         </p:spPr>
         <p:txBody>
-          <a:bodyPr lIns="45719" rIns="45719" anchor="ctr"/>
+          <a:bodyPr lIns="45718" tIns="45718" rIns="45718" bIns="45718" anchor="ctr"/>
           <a:lstStyle/>
           <a:p>
             <a:pPr algn="ctr">
@@ -6872,7 +6698,7 @@
         <p:spPr>
           <a:xfrm>
             <a:off x="594360" y="137159"/>
-            <a:ext cx="10881361" cy="489954"/>
+            <a:ext cx="10881361" cy="489952"/>
           </a:xfrm>
           <a:prstGeom prst="rect">
             <a:avLst/>
@@ -6887,7 +6713,7 @@
           </a:extLst>
         </p:spPr>
         <p:txBody>
-          <a:bodyPr lIns="45719" rIns="45719">
+          <a:bodyPr lIns="45718" tIns="45718" rIns="45718" bIns="45718">
             <a:spAutoFit/>
           </a:bodyPr>
           <a:lstStyle>
@@ -6915,8 +6741,8 @@
         </p:nvSpPr>
         <p:spPr>
           <a:xfrm>
-            <a:off x="594360" y="1280160"/>
-            <a:ext cx="5852161" cy="333088"/>
+            <a:off x="594359" y="1280161"/>
+            <a:ext cx="5852162" cy="333086"/>
           </a:xfrm>
           <a:prstGeom prst="rect">
             <a:avLst/>
@@ -6931,7 +6757,7 @@
           </a:extLst>
         </p:spPr>
         <p:txBody>
-          <a:bodyPr lIns="45719" rIns="45719">
+          <a:bodyPr lIns="45718" tIns="45718" rIns="45718" bIns="45718">
             <a:spAutoFit/>
           </a:bodyPr>
           <a:lstStyle>
@@ -6960,7 +6786,7 @@
         <p:spPr>
           <a:xfrm>
             <a:off x="548640" y="1828800"/>
-            <a:ext cx="5943601" cy="1005840"/>
+            <a:ext cx="5943602" cy="1005840"/>
           </a:xfrm>
           <a:prstGeom prst="roundRect">
             <a:avLst>
@@ -6984,7 +6810,7 @@
           </a:effectLst>
         </p:spPr>
         <p:txBody>
-          <a:bodyPr lIns="45719" rIns="45719" anchor="ctr"/>
+          <a:bodyPr lIns="45718" tIns="45718" rIns="45718" bIns="45718" anchor="ctr"/>
           <a:lstStyle/>
           <a:p>
             <a:pPr algn="ctr">
@@ -7005,8 +6831,8 @@
         </p:nvSpPr>
         <p:spPr>
           <a:xfrm>
-            <a:off x="777239" y="1920239"/>
-            <a:ext cx="1788435" cy="485141"/>
+            <a:off x="777238" y="1920239"/>
+            <a:ext cx="1788434" cy="485139"/>
           </a:xfrm>
           <a:prstGeom prst="rect">
             <a:avLst/>
@@ -7021,7 +6847,7 @@
           </a:extLst>
         </p:spPr>
         <p:txBody>
-          <a:bodyPr wrap="none" lIns="45719" rIns="45719">
+          <a:bodyPr wrap="none" lIns="45718" tIns="45718" rIns="45718" bIns="45718">
             <a:spAutoFit/>
           </a:bodyPr>
           <a:lstStyle/>
@@ -7073,8 +6899,8 @@
         </p:nvSpPr>
         <p:spPr>
           <a:xfrm>
-            <a:off x="594360" y="3017520"/>
-            <a:ext cx="5852161" cy="1545194"/>
+            <a:off x="594359" y="3017521"/>
+            <a:ext cx="5852162" cy="1608692"/>
           </a:xfrm>
           <a:prstGeom prst="rect">
             <a:avLst/>
@@ -7089,7 +6915,7 @@
           </a:extLst>
         </p:spPr>
         <p:txBody>
-          <a:bodyPr lIns="45719" rIns="45719">
+          <a:bodyPr lIns="45718" tIns="45718" rIns="45718" bIns="45718">
             <a:spAutoFit/>
           </a:bodyPr>
           <a:lstStyle/>
@@ -7108,7 +6934,11 @@
               </a:defRPr>
             </a:pPr>
             <a:r>
-              <a:t>class — keyword that starts a class definition</a:t>
+              <a:rPr b="1"/>
+              <a:t>class</a:t>
+            </a:r>
+            <a:r>
+              <a:t> — keyword that starts a class definition</a:t>
             </a:r>
           </a:p>
           <a:p>
@@ -7166,8 +6996,8 @@
         </p:nvSpPr>
         <p:spPr>
           <a:xfrm>
-            <a:off x="6629400" y="1280160"/>
-            <a:ext cx="5212081" cy="333088"/>
+            <a:off x="6629399" y="1280161"/>
+            <a:ext cx="5212083" cy="333086"/>
           </a:xfrm>
           <a:prstGeom prst="rect">
             <a:avLst/>
@@ -7182,7 +7012,7 @@
           </a:extLst>
         </p:spPr>
         <p:txBody>
-          <a:bodyPr lIns="45719" rIns="45719">
+          <a:bodyPr lIns="45718" tIns="45718" rIns="45718" bIns="45718">
             <a:spAutoFit/>
           </a:bodyPr>
           <a:lstStyle>
@@ -7211,7 +7041,7 @@
         <p:spPr>
           <a:xfrm>
             <a:off x="6583680" y="1828800"/>
-            <a:ext cx="5303521" cy="1005840"/>
+            <a:ext cx="5303522" cy="1005840"/>
           </a:xfrm>
           <a:prstGeom prst="roundRect">
             <a:avLst>
@@ -7235,7 +7065,7 @@
           </a:effectLst>
         </p:spPr>
         <p:txBody>
-          <a:bodyPr lIns="45719" rIns="45719" anchor="ctr"/>
+          <a:bodyPr lIns="45718" tIns="45718" rIns="45718" bIns="45718" anchor="ctr"/>
           <a:lstStyle/>
           <a:p>
             <a:pPr algn="ctr">
@@ -7256,8 +7086,8 @@
         </p:nvSpPr>
         <p:spPr>
           <a:xfrm>
-            <a:off x="6812279" y="1920239"/>
-            <a:ext cx="5256100" cy="485141"/>
+            <a:off x="6812278" y="1920239"/>
+            <a:ext cx="2184738" cy="485139"/>
           </a:xfrm>
           <a:prstGeom prst="rect">
             <a:avLst/>
@@ -7272,7 +7102,7 @@
           </a:extLst>
         </p:spPr>
         <p:txBody>
-          <a:bodyPr wrap="none" lIns="45719" rIns="45719">
+          <a:bodyPr wrap="none" lIns="45718" tIns="45718" rIns="45718" bIns="45718">
             <a:spAutoFit/>
           </a:bodyPr>
           <a:lstStyle/>
@@ -7311,7 +7141,7 @@
               </a:defRPr>
             </a:pPr>
             <a:r>
-              <a:t>print(type(sensor))  # &lt;class '__main__.LineSensor'&gt;</a:t>
+              <a:t>print(type(sensor)) </a:t>
             </a:r>
           </a:p>
         </p:txBody>
@@ -7324,8 +7154,8 @@
         </p:nvSpPr>
         <p:spPr>
           <a:xfrm>
-            <a:off x="6629400" y="3017520"/>
-            <a:ext cx="5212081" cy="577191"/>
+            <a:off x="6629399" y="3017521"/>
+            <a:ext cx="5212083" cy="577189"/>
           </a:xfrm>
           <a:prstGeom prst="rect">
             <a:avLst/>
@@ -7340,7 +7170,7 @@
           </a:extLst>
         </p:spPr>
         <p:txBody>
-          <a:bodyPr lIns="45719" rIns="45719">
+          <a:bodyPr lIns="45718" tIns="45718" rIns="45718" bIns="45718">
             <a:spAutoFit/>
           </a:bodyPr>
           <a:lstStyle>
@@ -7415,7 +7245,7 @@
           </a:effectLst>
         </p:spPr>
         <p:txBody>
-          <a:bodyPr lIns="45719" rIns="45719" anchor="ctr"/>
+          <a:bodyPr lIns="45718" tIns="45718" rIns="45718" bIns="45718" anchor="ctr"/>
           <a:lstStyle/>
           <a:p>
             <a:pPr algn="ctr">
@@ -7437,7 +7267,7 @@
         <p:spPr>
           <a:xfrm>
             <a:off x="594360" y="137159"/>
-            <a:ext cx="10881361" cy="489954"/>
+            <a:ext cx="10881361" cy="489952"/>
           </a:xfrm>
           <a:prstGeom prst="rect">
             <a:avLst/>
@@ -7452,7 +7282,7 @@
           </a:extLst>
         </p:spPr>
         <p:txBody>
-          <a:bodyPr lIns="45719" rIns="45719">
+          <a:bodyPr lIns="45718" tIns="45718" rIns="45718" bIns="45718">
             <a:spAutoFit/>
           </a:bodyPr>
           <a:lstStyle>
@@ -7480,8 +7310,8 @@
         </p:nvSpPr>
         <p:spPr>
           <a:xfrm>
-            <a:off x="594360" y="1188719"/>
-            <a:ext cx="10881361" cy="333089"/>
+            <a:off x="594360" y="1188720"/>
+            <a:ext cx="10881361" cy="333086"/>
           </a:xfrm>
           <a:prstGeom prst="rect">
             <a:avLst/>
@@ -7496,7 +7326,7 @@
           </a:extLst>
         </p:spPr>
         <p:txBody>
-          <a:bodyPr lIns="45719" rIns="45719">
+          <a:bodyPr lIns="45718" tIns="45718" rIns="45718" bIns="45718">
             <a:spAutoFit/>
           </a:bodyPr>
           <a:lstStyle>
@@ -7525,7 +7355,7 @@
         <p:spPr>
           <a:xfrm>
             <a:off x="548640" y="1737360"/>
-            <a:ext cx="9144001" cy="1828801"/>
+            <a:ext cx="9144001" cy="1828802"/>
           </a:xfrm>
           <a:prstGeom prst="roundRect">
             <a:avLst>
@@ -7549,7 +7379,7 @@
           </a:effectLst>
         </p:spPr>
         <p:txBody>
-          <a:bodyPr lIns="45719" rIns="45719" anchor="ctr"/>
+          <a:bodyPr lIns="45718" tIns="45718" rIns="45718" bIns="45718" anchor="ctr"/>
           <a:lstStyle/>
           <a:p>
             <a:pPr algn="ctr">
@@ -7570,8 +7400,8 @@
         </p:nvSpPr>
         <p:spPr>
           <a:xfrm>
-            <a:off x="777239" y="1828799"/>
-            <a:ext cx="6445013" cy="891541"/>
+            <a:off x="777238" y="1828800"/>
+            <a:ext cx="8396049" cy="1094739"/>
           </a:xfrm>
           <a:prstGeom prst="rect">
             <a:avLst/>
@@ -7586,7 +7416,7 @@
           </a:extLst>
         </p:spPr>
         <p:txBody>
-          <a:bodyPr wrap="none" lIns="45719" rIns="45719">
+          <a:bodyPr wrap="none" lIns="45718" tIns="45718" rIns="45718" bIns="45718">
             <a:spAutoFit/>
           </a:bodyPr>
           <a:lstStyle/>
@@ -7595,7 +7425,7 @@
               <a:spcBef>
                 <a:spcPts val="100"/>
               </a:spcBef>
-              <a:defRPr sz="1300">
+              <a:defRPr sz="1700">
                 <a:solidFill>
                   <a:srgbClr val="333333"/>
                 </a:solidFill>
@@ -7614,7 +7444,7 @@
               <a:spcBef>
                 <a:spcPts val="100"/>
               </a:spcBef>
-              <a:defRPr sz="1300">
+              <a:defRPr sz="1700">
                 <a:solidFill>
                   <a:srgbClr val="333333"/>
                 </a:solidFill>
@@ -7633,7 +7463,7 @@
               <a:spcBef>
                 <a:spcPts val="100"/>
               </a:spcBef>
-              <a:defRPr sz="1300">
+              <a:defRPr sz="1700">
                 <a:solidFill>
                   <a:srgbClr val="333333"/>
                 </a:solidFill>
@@ -7652,7 +7482,7 @@
               <a:spcBef>
                 <a:spcPts val="100"/>
               </a:spcBef>
-              <a:defRPr sz="1300">
+              <a:defRPr sz="1700">
                 <a:solidFill>
                   <a:srgbClr val="333333"/>
                 </a:solidFill>
@@ -7676,8 +7506,8 @@
         </p:nvSpPr>
         <p:spPr>
           <a:xfrm>
-            <a:off x="594360" y="3749038"/>
-            <a:ext cx="5852161" cy="1545195"/>
+            <a:off x="568501" y="4005144"/>
+            <a:ext cx="5852162" cy="1253092"/>
           </a:xfrm>
           <a:prstGeom prst="rect">
             <a:avLst/>
@@ -7692,13 +7522,10 @@
           </a:extLst>
         </p:spPr>
         <p:txBody>
-          <a:bodyPr lIns="45719" rIns="45719">
+          <a:bodyPr lIns="45718" tIns="45718" rIns="45718" bIns="45718">
             <a:spAutoFit/>
           </a:bodyPr>
           <a:lstStyle/>
-          <a:p>
-            <a:pPr/>
-          </a:p>
           <a:p>
             <a:pPr>
               <a:spcBef>
@@ -7769,8 +7596,8 @@
         </p:nvSpPr>
         <p:spPr>
           <a:xfrm>
-            <a:off x="6629400" y="3749038"/>
-            <a:ext cx="5212081" cy="333089"/>
+            <a:off x="6629399" y="3749038"/>
+            <a:ext cx="5212083" cy="333087"/>
           </a:xfrm>
           <a:prstGeom prst="rect">
             <a:avLst/>
@@ -7785,7 +7612,7 @@
           </a:extLst>
         </p:spPr>
         <p:txBody>
-          <a:bodyPr lIns="45719" rIns="45719">
+          <a:bodyPr lIns="45718" tIns="45718" rIns="45718" bIns="45718">
             <a:spAutoFit/>
           </a:bodyPr>
           <a:lstStyle>
@@ -7814,7 +7641,7 @@
         <p:spPr>
           <a:xfrm>
             <a:off x="6583680" y="4297679"/>
-            <a:ext cx="5303521" cy="1005841"/>
+            <a:ext cx="5303522" cy="1005842"/>
           </a:xfrm>
           <a:prstGeom prst="roundRect">
             <a:avLst>
@@ -7838,7 +7665,7 @@
           </a:effectLst>
         </p:spPr>
         <p:txBody>
-          <a:bodyPr lIns="45719" rIns="45719" anchor="ctr"/>
+          <a:bodyPr lIns="45718" tIns="45718" rIns="45718" bIns="45718" anchor="ctr"/>
           <a:lstStyle/>
           <a:p>
             <a:pPr algn="ctr">
@@ -7859,8 +7686,8 @@
         </p:nvSpPr>
         <p:spPr>
           <a:xfrm>
-            <a:off x="6812279" y="4389120"/>
-            <a:ext cx="4958871" cy="485141"/>
+            <a:off x="6812278" y="4389121"/>
+            <a:ext cx="4958869" cy="485139"/>
           </a:xfrm>
           <a:prstGeom prst="rect">
             <a:avLst/>
@@ -7875,7 +7702,7 @@
           </a:extLst>
         </p:spPr>
         <p:txBody>
-          <a:bodyPr wrap="none" lIns="45719" rIns="45719">
+          <a:bodyPr wrap="none" lIns="45718" tIns="45718" rIns="45718" bIns="45718">
             <a:spAutoFit/>
           </a:bodyPr>
           <a:lstStyle/>
@@ -7927,8 +7754,8 @@
         </p:nvSpPr>
         <p:spPr>
           <a:xfrm>
-            <a:off x="594360" y="5852159"/>
-            <a:ext cx="6204977" cy="330286"/>
+            <a:off x="594359" y="5852160"/>
+            <a:ext cx="6204976" cy="330283"/>
           </a:xfrm>
           <a:prstGeom prst="rect">
             <a:avLst/>
@@ -7943,7 +7770,7 @@
           </a:extLst>
         </p:spPr>
         <p:txBody>
-          <a:bodyPr wrap="none" lIns="45719" rIns="45719">
+          <a:bodyPr wrap="none" lIns="45718" tIns="45718" rIns="45718" bIns="45718">
             <a:spAutoFit/>
           </a:bodyPr>
           <a:lstStyle>
@@ -8018,7 +7845,7 @@
           </a:effectLst>
         </p:spPr>
         <p:txBody>
-          <a:bodyPr lIns="45719" rIns="45719" anchor="ctr"/>
+          <a:bodyPr lIns="45718" tIns="45718" rIns="45718" bIns="45718" anchor="ctr"/>
           <a:lstStyle/>
           <a:p>
             <a:pPr algn="ctr">
@@ -8040,7 +7867,7 @@
         <p:spPr>
           <a:xfrm>
             <a:off x="594360" y="137159"/>
-            <a:ext cx="10881361" cy="489954"/>
+            <a:ext cx="10881361" cy="489952"/>
           </a:xfrm>
           <a:prstGeom prst="rect">
             <a:avLst/>
@@ -8055,7 +7882,7 @@
           </a:extLst>
         </p:spPr>
         <p:txBody>
-          <a:bodyPr lIns="45719" rIns="45719">
+          <a:bodyPr lIns="45718" tIns="45718" rIns="45718" bIns="45718">
             <a:spAutoFit/>
           </a:bodyPr>
           <a:lstStyle>
@@ -8108,7 +7935,7 @@
           </a:effectLst>
         </p:spPr>
         <p:txBody>
-          <a:bodyPr lIns="45719" rIns="45719" anchor="ctr"/>
+          <a:bodyPr lIns="45718" tIns="45718" rIns="45718" bIns="45718" anchor="ctr"/>
           <a:lstStyle/>
           <a:p>
             <a:pPr algn="ctr">
@@ -8129,8 +7956,8 @@
         </p:nvSpPr>
         <p:spPr>
           <a:xfrm>
-            <a:off x="777239" y="1463039"/>
-            <a:ext cx="5652404" cy="1704341"/>
+            <a:off x="777239" y="1463040"/>
+            <a:ext cx="5652402" cy="1704339"/>
           </a:xfrm>
           <a:prstGeom prst="rect">
             <a:avLst/>
@@ -8145,7 +7972,7 @@
           </a:extLst>
         </p:spPr>
         <p:txBody>
-          <a:bodyPr wrap="none" lIns="45719" rIns="45719">
+          <a:bodyPr wrap="none" lIns="45718" tIns="45718" rIns="45718" bIns="45718">
             <a:spAutoFit/>
           </a:bodyPr>
           <a:lstStyle/>
@@ -8308,8 +8135,8 @@
         </p:nvSpPr>
         <p:spPr>
           <a:xfrm>
-            <a:off x="594360" y="4663440"/>
-            <a:ext cx="10881361" cy="310491"/>
+            <a:off x="594360" y="4663441"/>
+            <a:ext cx="10881361" cy="310489"/>
           </a:xfrm>
           <a:prstGeom prst="rect">
             <a:avLst/>
@@ -8324,7 +8151,7 @@
           </a:extLst>
         </p:spPr>
         <p:txBody>
-          <a:bodyPr lIns="45719" rIns="45719">
+          <a:bodyPr lIns="45718" tIns="45718" rIns="45718" bIns="45718">
             <a:spAutoFit/>
           </a:bodyPr>
           <a:lstStyle>
@@ -8353,7 +8180,7 @@
         <p:spPr>
           <a:xfrm>
             <a:off x="548640" y="5212079"/>
-            <a:ext cx="6858001" cy="1645921"/>
+            <a:ext cx="6858001" cy="1645922"/>
           </a:xfrm>
           <a:prstGeom prst="roundRect">
             <a:avLst>
@@ -8377,7 +8204,7 @@
           </a:effectLst>
         </p:spPr>
         <p:txBody>
-          <a:bodyPr lIns="45719" rIns="45719" anchor="ctr"/>
+          <a:bodyPr lIns="45718" tIns="45718" rIns="45718" bIns="45718" anchor="ctr"/>
           <a:lstStyle/>
           <a:p>
             <a:pPr algn="ctr">
@@ -8398,8 +8225,8 @@
         </p:nvSpPr>
         <p:spPr>
           <a:xfrm>
-            <a:off x="777239" y="5303520"/>
-            <a:ext cx="4760719" cy="1297941"/>
+            <a:off x="777238" y="5303521"/>
+            <a:ext cx="4760717" cy="1297939"/>
           </a:xfrm>
           <a:prstGeom prst="rect">
             <a:avLst/>
@@ -8414,7 +8241,7 @@
           </a:extLst>
         </p:spPr>
         <p:txBody>
-          <a:bodyPr wrap="none" lIns="45719" rIns="45719">
+          <a:bodyPr wrap="none" lIns="45718" tIns="45718" rIns="45718" bIns="45718">
             <a:spAutoFit/>
           </a:bodyPr>
           <a:lstStyle/>
@@ -8540,7 +8367,7 @@
         <p:spPr>
           <a:xfrm>
             <a:off x="7635239" y="1371600"/>
-            <a:ext cx="4297681" cy="1976994"/>
+            <a:ext cx="4297682" cy="2040493"/>
           </a:xfrm>
           <a:prstGeom prst="rect">
             <a:avLst/>
@@ -8555,7 +8382,7 @@
           </a:extLst>
         </p:spPr>
         <p:txBody>
-          <a:bodyPr lIns="45719" rIns="45719">
+          <a:bodyPr lIns="45718" tIns="45718" rIns="45718" bIns="45718">
             <a:spAutoFit/>
           </a:bodyPr>
           <a:lstStyle/>
@@ -8582,12 +8409,12 @@
               <a:spcBef>
                 <a:spcPts val="500"/>
               </a:spcBef>
-            </a:pPr>
-            <a:endParaRPr b="1">
-              <a:solidFill>
-                <a:srgbClr val="1B3A5C"/>
-              </a:solidFill>
-            </a:endParaRPr>
+              <a:defRPr b="1">
+                <a:solidFill>
+                  <a:srgbClr val="1B3A5C"/>
+                </a:solidFill>
+              </a:defRPr>
+            </a:pPr>
           </a:p>
           <a:p>
             <a:pPr>
@@ -8691,7 +8518,7 @@
           </a:effectLst>
         </p:spPr>
         <p:txBody>
-          <a:bodyPr lIns="45719" rIns="45719" anchor="ctr"/>
+          <a:bodyPr lIns="45718" tIns="45718" rIns="45718" bIns="45718" anchor="ctr"/>
           <a:lstStyle/>
           <a:p>
             <a:pPr algn="ctr">
@@ -8713,7 +8540,7 @@
         <p:spPr>
           <a:xfrm>
             <a:off x="594360" y="137159"/>
-            <a:ext cx="10881361" cy="489954"/>
+            <a:ext cx="10881361" cy="489952"/>
           </a:xfrm>
           <a:prstGeom prst="rect">
             <a:avLst/>
@@ -8728,7 +8555,7 @@
           </a:extLst>
         </p:spPr>
         <p:txBody>
-          <a:bodyPr lIns="45719" rIns="45719">
+          <a:bodyPr lIns="45718" tIns="45718" rIns="45718" bIns="45718">
             <a:spAutoFit/>
           </a:bodyPr>
           <a:lstStyle>
@@ -8756,8 +8583,8 @@
         </p:nvSpPr>
         <p:spPr>
           <a:xfrm>
-            <a:off x="594360" y="1188719"/>
-            <a:ext cx="10881361" cy="333089"/>
+            <a:off x="594360" y="1188720"/>
+            <a:ext cx="10881361" cy="333086"/>
           </a:xfrm>
           <a:prstGeom prst="rect">
             <a:avLst/>
@@ -8772,7 +8599,7 @@
           </a:extLst>
         </p:spPr>
         <p:txBody>
-          <a:bodyPr lIns="45719" rIns="45719">
+          <a:bodyPr lIns="45718" tIns="45718" rIns="45718" bIns="45718">
             <a:spAutoFit/>
           </a:bodyPr>
           <a:lstStyle>
@@ -8801,7 +8628,7 @@
         <p:spPr>
           <a:xfrm>
             <a:off x="548640" y="1737360"/>
-            <a:ext cx="6858001" cy="2903220"/>
+            <a:ext cx="6858001" cy="2903221"/>
           </a:xfrm>
           <a:prstGeom prst="roundRect">
             <a:avLst>
@@ -8825,7 +8652,7 @@
           </a:effectLst>
         </p:spPr>
         <p:txBody>
-          <a:bodyPr lIns="45719" rIns="45719" anchor="ctr"/>
+          <a:bodyPr lIns="45718" tIns="45718" rIns="45718" bIns="45718" anchor="ctr"/>
           <a:lstStyle/>
           <a:p>
             <a:pPr algn="ctr">
@@ -8846,8 +8673,8 @@
         </p:nvSpPr>
         <p:spPr>
           <a:xfrm>
-            <a:off x="777239" y="1828800"/>
-            <a:ext cx="6445013" cy="2720340"/>
+            <a:off x="777238" y="1828801"/>
+            <a:ext cx="6445011" cy="1501139"/>
           </a:xfrm>
           <a:prstGeom prst="rect">
             <a:avLst/>
@@ -8862,7 +8689,7 @@
           </a:extLst>
         </p:spPr>
         <p:txBody>
-          <a:bodyPr wrap="none" lIns="45719" rIns="45719">
+          <a:bodyPr wrap="none" lIns="45718" tIns="45718" rIns="45718" bIns="45718">
             <a:spAutoFit/>
           </a:bodyPr>
           <a:lstStyle/>
@@ -8940,114 +8767,6 @@
             </a:pPr>
             <a:r>
               <a:t>        self.threshold = 0.5</a:t>
-            </a:r>
-          </a:p>
-          <a:p>
-            <a:pPr>
-              <a:spcBef>
-                <a:spcPts val="100"/>
-              </a:spcBef>
-              <a:defRPr sz="1300">
-                <a:solidFill>
-                  <a:srgbClr val="333333"/>
-                </a:solidFill>
-                <a:latin typeface="Courier New"/>
-                <a:ea typeface="Courier New"/>
-                <a:cs typeface="Courier New"/>
-                <a:sym typeface="Courier New"/>
-              </a:defRPr>
-            </a:pPr>
-          </a:p>
-          <a:p>
-            <a:pPr>
-              <a:spcBef>
-                <a:spcPts val="100"/>
-              </a:spcBef>
-              <a:defRPr sz="1300">
-                <a:solidFill>
-                  <a:srgbClr val="333333"/>
-                </a:solidFill>
-                <a:latin typeface="Courier New"/>
-                <a:ea typeface="Courier New"/>
-                <a:cs typeface="Courier New"/>
-                <a:sym typeface="Courier New"/>
-              </a:defRPr>
-            </a:pPr>
-            <a:r>
-              <a:t>    def get_left(self):</a:t>
-            </a:r>
-          </a:p>
-          <a:p>
-            <a:pPr>
-              <a:spcBef>
-                <a:spcPts val="100"/>
-              </a:spcBef>
-              <a:defRPr sz="1300">
-                <a:solidFill>
-                  <a:srgbClr val="333333"/>
-                </a:solidFill>
-                <a:latin typeface="Courier New"/>
-                <a:ea typeface="Courier New"/>
-                <a:cs typeface="Courier New"/>
-                <a:sym typeface="Courier New"/>
-              </a:defRPr>
-            </a:pPr>
-            <a:r>
-              <a:t>        return self.reflectance.get_left()</a:t>
-            </a:r>
-          </a:p>
-          <a:p>
-            <a:pPr>
-              <a:spcBef>
-                <a:spcPts val="100"/>
-              </a:spcBef>
-              <a:defRPr sz="1300">
-                <a:solidFill>
-                  <a:srgbClr val="333333"/>
-                </a:solidFill>
-                <a:latin typeface="Courier New"/>
-                <a:ea typeface="Courier New"/>
-                <a:cs typeface="Courier New"/>
-                <a:sym typeface="Courier New"/>
-              </a:defRPr>
-            </a:pPr>
-          </a:p>
-          <a:p>
-            <a:pPr>
-              <a:spcBef>
-                <a:spcPts val="100"/>
-              </a:spcBef>
-              <a:defRPr sz="1300">
-                <a:solidFill>
-                  <a:srgbClr val="333333"/>
-                </a:solidFill>
-                <a:latin typeface="Courier New"/>
-                <a:ea typeface="Courier New"/>
-                <a:cs typeface="Courier New"/>
-                <a:sym typeface="Courier New"/>
-              </a:defRPr>
-            </a:pPr>
-            <a:r>
-              <a:t>    def get_right(self):</a:t>
-            </a:r>
-          </a:p>
-          <a:p>
-            <a:pPr>
-              <a:spcBef>
-                <a:spcPts val="100"/>
-              </a:spcBef>
-              <a:defRPr sz="1300">
-                <a:solidFill>
-                  <a:srgbClr val="333333"/>
-                </a:solidFill>
-                <a:latin typeface="Courier New"/>
-                <a:ea typeface="Courier New"/>
-                <a:cs typeface="Courier New"/>
-                <a:sym typeface="Courier New"/>
-              </a:defRPr>
-            </a:pPr>
-            <a:r>
-              <a:t>        return self.reflectance.get_right()</a:t>
             </a:r>
           </a:p>
           <a:p>
@@ -9114,8 +8833,8 @@
         </p:nvSpPr>
         <p:spPr>
           <a:xfrm>
-            <a:off x="7543798" y="1737360"/>
-            <a:ext cx="4389121" cy="1900794"/>
+            <a:off x="7543797" y="1737361"/>
+            <a:ext cx="4389122" cy="1964292"/>
           </a:xfrm>
           <a:prstGeom prst="rect">
             <a:avLst/>
@@ -9130,7 +8849,7 @@
           </a:extLst>
         </p:spPr>
         <p:txBody>
-          <a:bodyPr lIns="45719" rIns="45719">
+          <a:bodyPr lIns="45718" tIns="45718" rIns="45718" bIns="45718">
             <a:spAutoFit/>
           </a:bodyPr>
           <a:lstStyle/>
@@ -9209,7 +8928,7 @@
               </a:defRPr>
             </a:pPr>
             <a:r>
-              <a:t>Use self. to call other methods (self.get_left())</a:t>
+              <a:t>Use self. to call other methods (self.get_error())</a:t>
             </a:r>
           </a:p>
         </p:txBody>
@@ -9222,8 +8941,8 @@
         </p:nvSpPr>
         <p:spPr>
           <a:xfrm>
-            <a:off x="675004" y="4967649"/>
-            <a:ext cx="10881361" cy="300594"/>
+            <a:off x="675004" y="4967650"/>
+            <a:ext cx="10881361" cy="300592"/>
           </a:xfrm>
           <a:prstGeom prst="rect">
             <a:avLst/>
@@ -9238,7 +8957,7 @@
           </a:extLst>
         </p:spPr>
         <p:txBody>
-          <a:bodyPr lIns="45719" rIns="45719">
+          <a:bodyPr lIns="45718" tIns="45718" rIns="45718" bIns="45718">
             <a:spAutoFit/>
           </a:bodyPr>
           <a:lstStyle>
@@ -9267,7 +8986,7 @@
         <p:spPr>
           <a:xfrm>
             <a:off x="629284" y="5424849"/>
-            <a:ext cx="6858001" cy="1188721"/>
+            <a:ext cx="6858001" cy="1188722"/>
           </a:xfrm>
           <a:prstGeom prst="roundRect">
             <a:avLst>
@@ -9291,7 +9010,7 @@
           </a:effectLst>
         </p:spPr>
         <p:txBody>
-          <a:bodyPr lIns="45719" rIns="45719" anchor="ctr"/>
+          <a:bodyPr lIns="45718" tIns="45718" rIns="45718" bIns="45718" anchor="ctr"/>
           <a:lstStyle/>
           <a:p>
             <a:pPr algn="ctr">
@@ -9312,8 +9031,8 @@
         </p:nvSpPr>
         <p:spPr>
           <a:xfrm>
-            <a:off x="857884" y="5516289"/>
-            <a:ext cx="4661643" cy="688341"/>
+            <a:off x="857883" y="5516289"/>
+            <a:ext cx="4364413" cy="688339"/>
           </a:xfrm>
           <a:prstGeom prst="rect">
             <a:avLst/>
@@ -9328,7 +9047,7 @@
           </a:extLst>
         </p:spPr>
         <p:txBody>
-          <a:bodyPr wrap="none" lIns="45719" rIns="45719">
+          <a:bodyPr wrap="none" lIns="45718" tIns="45718" rIns="45718" bIns="45718">
             <a:spAutoFit/>
           </a:bodyPr>
           <a:lstStyle/>
@@ -9366,9 +9085,6 @@
                 <a:sym typeface="Courier New"/>
               </a:defRPr>
             </a:pPr>
-            <a:r>
-              <a:t>print(sensor.get_left())    # Read left sensor</a:t>
-            </a:r>
           </a:p>
           <a:p>
             <a:pPr>
@@ -9446,7 +9162,7 @@
           </a:effectLst>
         </p:spPr>
         <p:txBody>
-          <a:bodyPr lIns="45719" rIns="45719" anchor="ctr"/>
+          <a:bodyPr lIns="45718" tIns="45718" rIns="45718" bIns="45718" anchor="ctr"/>
           <a:lstStyle/>
           <a:p>
             <a:pPr algn="ctr">
@@ -9468,7 +9184,7 @@
         <p:spPr>
           <a:xfrm>
             <a:off x="594360" y="137159"/>
-            <a:ext cx="10881361" cy="489954"/>
+            <a:ext cx="10881361" cy="489952"/>
           </a:xfrm>
           <a:prstGeom prst="rect">
             <a:avLst/>
@@ -9483,7 +9199,7 @@
           </a:extLst>
         </p:spPr>
         <p:txBody>
-          <a:bodyPr lIns="45719" rIns="45719">
+          <a:bodyPr lIns="45718" tIns="45718" rIns="45718" bIns="45718">
             <a:spAutoFit/>
           </a:bodyPr>
           <a:lstStyle>
@@ -9511,8 +9227,8 @@
         </p:nvSpPr>
         <p:spPr>
           <a:xfrm>
-            <a:off x="594360" y="1188719"/>
-            <a:ext cx="10881361" cy="333089"/>
+            <a:off x="594360" y="1188720"/>
+            <a:ext cx="10881361" cy="333086"/>
           </a:xfrm>
           <a:prstGeom prst="rect">
             <a:avLst/>
@@ -9527,7 +9243,7 @@
           </a:extLst>
         </p:spPr>
         <p:txBody>
-          <a:bodyPr lIns="45719" rIns="45719">
+          <a:bodyPr lIns="45718" tIns="45718" rIns="45718" bIns="45718">
             <a:spAutoFit/>
           </a:bodyPr>
           <a:lstStyle>
@@ -9556,7 +9272,7 @@
         <p:spPr>
           <a:xfrm>
             <a:off x="548640" y="1737360"/>
-            <a:ext cx="10972801" cy="1371601"/>
+            <a:ext cx="10972801" cy="1371602"/>
           </a:xfrm>
           <a:prstGeom prst="roundRect">
             <a:avLst>
@@ -9580,7 +9296,7 @@
           </a:effectLst>
         </p:spPr>
         <p:txBody>
-          <a:bodyPr lIns="45719" rIns="45719" anchor="ctr"/>
+          <a:bodyPr lIns="45718" tIns="45718" rIns="45718" bIns="45718" anchor="ctr"/>
           <a:lstStyle/>
           <a:p>
             <a:pPr algn="ctr">
@@ -9601,8 +9317,8 @@
         </p:nvSpPr>
         <p:spPr>
           <a:xfrm>
-            <a:off x="777239" y="1828799"/>
-            <a:ext cx="8129307" cy="1094741"/>
+            <a:off x="777239" y="1828800"/>
+            <a:ext cx="8129305" cy="1094739"/>
           </a:xfrm>
           <a:prstGeom prst="rect">
             <a:avLst/>
@@ -9617,7 +9333,7 @@
           </a:extLst>
         </p:spPr>
         <p:txBody>
-          <a:bodyPr wrap="none" lIns="45719" rIns="45719">
+          <a:bodyPr wrap="none" lIns="45718" tIns="45718" rIns="45718" bIns="45718">
             <a:spAutoFit/>
           </a:bodyPr>
           <a:lstStyle/>
@@ -9722,8 +9438,8 @@
           <p:nvPr/>
         </p:nvGraphicFramePr>
         <p:xfrm>
-          <a:off x="450731" y="3386455"/>
-          <a:ext cx="9144001" cy="1920241"/>
+          <a:off x="450731" y="3386454"/>
+          <a:ext cx="9144001" cy="1920242"/>
         </p:xfrm>
         <a:graphic xmlns:a="http://schemas.openxmlformats.org/drawingml/2006/main">
           <a:graphicData uri="http://schemas.openxmlformats.org/drawingml/2006/table">
@@ -9907,7 +9623,7 @@
                       </a:pPr>
                       <a:r>
                         <a:rPr sz="1300"/>
-                        <a:t>high</a:t>
+                        <a:t>midpoint</a:t>
                       </a:r>
                     </a:p>
                   </a:txBody>
@@ -9923,7 +9639,7 @@
                       </a:pPr>
                       <a:r>
                         <a:rPr sz="1300"/>
-                        <a:t>low</a:t>
+                        <a:t>midpoint</a:t>
                       </a:r>
                     </a:p>
                   </a:txBody>
@@ -10260,8 +9976,8 @@
         </p:nvSpPr>
         <p:spPr>
           <a:xfrm>
-            <a:off x="436569" y="5486400"/>
-            <a:ext cx="6858001" cy="1277621"/>
+            <a:off x="436568" y="5486400"/>
+            <a:ext cx="6858002" cy="1277622"/>
           </a:xfrm>
           <a:prstGeom prst="roundRect">
             <a:avLst>
@@ -10285,7 +10001,7 @@
           </a:effectLst>
         </p:spPr>
         <p:txBody>
-          <a:bodyPr lIns="45719" rIns="45719" anchor="ctr"/>
+          <a:bodyPr lIns="45718" tIns="45718" rIns="45718" bIns="45718" anchor="ctr"/>
           <a:lstStyle/>
           <a:p>
             <a:pPr algn="ctr">
@@ -10306,8 +10022,8 @@
         </p:nvSpPr>
         <p:spPr>
           <a:xfrm>
-            <a:off x="594359" y="5577840"/>
-            <a:ext cx="3175501" cy="1094741"/>
+            <a:off x="594358" y="5577841"/>
+            <a:ext cx="3175499" cy="1094739"/>
           </a:xfrm>
           <a:prstGeom prst="rect">
             <a:avLst/>
@@ -10322,7 +10038,7 @@
           </a:extLst>
         </p:spPr>
         <p:txBody>
-          <a:bodyPr wrap="none" lIns="45719" rIns="45719">
+          <a:bodyPr wrap="none" lIns="45718" tIns="45718" rIns="45718" bIns="45718">
             <a:spAutoFit/>
           </a:bodyPr>
           <a:lstStyle/>
@@ -10472,14 +10188,14 @@
     </a:clrScheme>
     <a:fontScheme name="Office Theme">
       <a:majorFont>
+        <a:latin typeface="Calibri"/>
+        <a:ea typeface="Calibri"/>
+        <a:cs typeface="Calibri"/>
+      </a:majorFont>
+      <a:minorFont>
         <a:latin typeface="Helvetica"/>
         <a:ea typeface="Helvetica"/>
         <a:cs typeface="Helvetica"/>
-      </a:majorFont>
-      <a:minorFont>
-        <a:latin typeface="Calibri"/>
-        <a:ea typeface="Calibri"/>
-        <a:cs typeface="Calibri"/>
       </a:minorFont>
     </a:fontScheme>
     <a:fmtScheme name="Office Theme">
@@ -10574,9 +10290,9 @@
         </a:effectStyle>
         <a:effectStyle>
           <a:effectLst>
-            <a:outerShdw sx="100000" sy="100000" kx="0" ky="0" algn="b" rotWithShape="0" blurRad="38100" dist="20000" dir="5400000">
+            <a:outerShdw sx="100000" sy="100000" kx="0" ky="0" algn="b" rotWithShape="0" blurRad="38100" dist="23000" dir="5400000">
               <a:srgbClr val="000000">
-                <a:alpha val="38000"/>
+                <a:alpha val="35000"/>
               </a:srgbClr>
             </a:outerShdw>
           </a:effectLst>
@@ -10656,7 +10372,7 @@
         </a:effectLst>
         <a:sp3d/>
       </a:spPr>
-      <a:bodyPr rot="0" spcFirstLastPara="1" vertOverflow="overflow" horzOverflow="overflow" vert="horz" wrap="square" lIns="45719" tIns="45719" rIns="45719" bIns="45719" numCol="1" spcCol="38100" rtlCol="0" anchor="ctr" upright="0">
+      <a:bodyPr rot="0" spcFirstLastPara="1" vertOverflow="overflow" horzOverflow="overflow" vert="horz" wrap="square" lIns="45718" tIns="45718" rIns="45718" bIns="45718" numCol="1" spcCol="38100" rtlCol="0" anchor="ctr" upright="0">
         <a:spAutoFit/>
       </a:bodyPr>
       <a:lstStyle>
@@ -10684,9 +10400,9 @@
             </a:solidFill>
             <a:effectLst/>
             <a:uFillTx/>
-            <a:latin typeface="+mn-lt"/>
-            <a:ea typeface="+mn-ea"/>
-            <a:cs typeface="+mn-cs"/>
+            <a:latin typeface="+mj-lt"/>
+            <a:ea typeface="+mj-ea"/>
+            <a:cs typeface="+mj-cs"/>
             <a:sym typeface="Calibri"/>
           </a:defRPr>
         </a:defPPr>
@@ -10943,9 +10659,9 @@
           <a:round/>
         </a:ln>
         <a:effectLst>
-          <a:outerShdw sx="100000" sy="100000" kx="0" ky="0" algn="b" rotWithShape="0" blurRad="38100" dist="20000" dir="5400000">
+          <a:outerShdw sx="100000" sy="100000" kx="0" ky="0" algn="b" rotWithShape="0" blurRad="38100" dist="23000" dir="5400000">
             <a:srgbClr val="000000">
-              <a:alpha val="38000"/>
+              <a:alpha val="35000"/>
             </a:srgbClr>
           </a:outerShdw>
         </a:effectLst>
@@ -11233,7 +10949,7 @@
         <a:effectLst/>
         <a:sp3d/>
       </a:spPr>
-      <a:bodyPr rot="0" spcFirstLastPara="1" vertOverflow="overflow" horzOverflow="overflow" vert="horz" wrap="square" lIns="45719" tIns="45719" rIns="45719" bIns="45719" numCol="1" spcCol="38100" rtlCol="0" anchor="t" upright="0">
+      <a:bodyPr rot="0" spcFirstLastPara="1" vertOverflow="overflow" horzOverflow="overflow" vert="horz" wrap="square" lIns="45718" tIns="45718" rIns="45718" bIns="45718" numCol="1" spcCol="38100" rtlCol="0" anchor="t" upright="0">
         <a:spAutoFit/>
       </a:bodyPr>
       <a:lstStyle>
@@ -11261,9 +10977,9 @@
             </a:solidFill>
             <a:effectLst/>
             <a:uFillTx/>
-            <a:latin typeface="+mn-lt"/>
-            <a:ea typeface="+mn-ea"/>
-            <a:cs typeface="+mn-cs"/>
+            <a:latin typeface="+mj-lt"/>
+            <a:ea typeface="+mj-ea"/>
+            <a:cs typeface="+mj-cs"/>
             <a:sym typeface="Calibri"/>
           </a:defRPr>
         </a:defPPr>
@@ -11556,14 +11272,14 @@
     </a:clrScheme>
     <a:fontScheme name="Office Theme">
       <a:majorFont>
+        <a:latin typeface="Calibri"/>
+        <a:ea typeface="Calibri"/>
+        <a:cs typeface="Calibri"/>
+      </a:majorFont>
+      <a:minorFont>
         <a:latin typeface="Helvetica"/>
         <a:ea typeface="Helvetica"/>
         <a:cs typeface="Helvetica"/>
-      </a:majorFont>
-      <a:minorFont>
-        <a:latin typeface="Calibri"/>
-        <a:ea typeface="Calibri"/>
-        <a:cs typeface="Calibri"/>
       </a:minorFont>
     </a:fontScheme>
     <a:fmtScheme name="Office Theme">
@@ -11658,9 +11374,9 @@
         </a:effectStyle>
         <a:effectStyle>
           <a:effectLst>
-            <a:outerShdw sx="100000" sy="100000" kx="0" ky="0" algn="b" rotWithShape="0" blurRad="38100" dist="20000" dir="5400000">
+            <a:outerShdw sx="100000" sy="100000" kx="0" ky="0" algn="b" rotWithShape="0" blurRad="38100" dist="23000" dir="5400000">
               <a:srgbClr val="000000">
-                <a:alpha val="38000"/>
+                <a:alpha val="35000"/>
               </a:srgbClr>
             </a:outerShdw>
           </a:effectLst>
@@ -11740,7 +11456,7 @@
         </a:effectLst>
         <a:sp3d/>
       </a:spPr>
-      <a:bodyPr rot="0" spcFirstLastPara="1" vertOverflow="overflow" horzOverflow="overflow" vert="horz" wrap="square" lIns="45719" tIns="45719" rIns="45719" bIns="45719" numCol="1" spcCol="38100" rtlCol="0" anchor="ctr" upright="0">
+      <a:bodyPr rot="0" spcFirstLastPara="1" vertOverflow="overflow" horzOverflow="overflow" vert="horz" wrap="square" lIns="45718" tIns="45718" rIns="45718" bIns="45718" numCol="1" spcCol="38100" rtlCol="0" anchor="ctr" upright="0">
         <a:spAutoFit/>
       </a:bodyPr>
       <a:lstStyle>
@@ -11768,9 +11484,9 @@
             </a:solidFill>
             <a:effectLst/>
             <a:uFillTx/>
-            <a:latin typeface="+mn-lt"/>
-            <a:ea typeface="+mn-ea"/>
-            <a:cs typeface="+mn-cs"/>
+            <a:latin typeface="+mj-lt"/>
+            <a:ea typeface="+mj-ea"/>
+            <a:cs typeface="+mj-cs"/>
             <a:sym typeface="Calibri"/>
           </a:defRPr>
         </a:defPPr>
@@ -12027,9 +11743,9 @@
           <a:round/>
         </a:ln>
         <a:effectLst>
-          <a:outerShdw sx="100000" sy="100000" kx="0" ky="0" algn="b" rotWithShape="0" blurRad="38100" dist="20000" dir="5400000">
+          <a:outerShdw sx="100000" sy="100000" kx="0" ky="0" algn="b" rotWithShape="0" blurRad="38100" dist="23000" dir="5400000">
             <a:srgbClr val="000000">
-              <a:alpha val="38000"/>
+              <a:alpha val="35000"/>
             </a:srgbClr>
           </a:outerShdw>
         </a:effectLst>
@@ -12317,7 +12033,7 @@
         <a:effectLst/>
         <a:sp3d/>
       </a:spPr>
-      <a:bodyPr rot="0" spcFirstLastPara="1" vertOverflow="overflow" horzOverflow="overflow" vert="horz" wrap="square" lIns="45719" tIns="45719" rIns="45719" bIns="45719" numCol="1" spcCol="38100" rtlCol="0" anchor="t" upright="0">
+      <a:bodyPr rot="0" spcFirstLastPara="1" vertOverflow="overflow" horzOverflow="overflow" vert="horz" wrap="square" lIns="45718" tIns="45718" rIns="45718" bIns="45718" numCol="1" spcCol="38100" rtlCol="0" anchor="t" upright="0">
         <a:spAutoFit/>
       </a:bodyPr>
       <a:lstStyle>
@@ -12345,9 +12061,9 @@
             </a:solidFill>
             <a:effectLst/>
             <a:uFillTx/>
-            <a:latin typeface="+mn-lt"/>
-            <a:ea typeface="+mn-ea"/>
-            <a:cs typeface="+mn-cs"/>
+            <a:latin typeface="+mj-lt"/>
+            <a:ea typeface="+mj-ea"/>
+            <a:cs typeface="+mj-cs"/>
             <a:sym typeface="Calibri"/>
           </a:defRPr>
         </a:defPPr>

</xml_diff>